<commit_message>
docs(presentation): update niva pitch deck (expanded slides + rebuilt outputs)
Co-Authored-By: Claude Opus 4.8 (1M context) <noreply@anthropic.com>
</commit_message>
<xml_diff>
--- a/presentation/niva_pitch.pptx
+++ b/presentation/niva_pitch.pptx
@@ -21,6 +21,8 @@
     <p:sldId id="269" r:id="rId20"/>
     <p:sldId id="270" r:id="rId21"/>
     <p:sldId id="271" r:id="rId22"/>
+    <p:sldId id="272" r:id="rId23"/>
+    <p:sldId id="273" r:id="rId24"/>
   </p:sldIdLst>
   <p:sldSz cx="12191695" cy="6858000" type="screen4x3"/>
   <p:notesSz cx="6858000" cy="9144000"/>
@@ -3559,7 +3561,7 @@
         </p:nvSpPr>
         <p:spPr>
           <a:xfrm>
-            <a:off x="502920" y="6455664"/>
+            <a:off x="502920" y="6437376"/>
             <a:ext cx="5486400" cy="365760"/>
           </a:xfrm>
           <a:prstGeom prst="rect">
@@ -3579,7 +3581,7 @@
               </a:lnSpc>
             </a:pPr>
             <a:r>
-              <a:rPr sz="1100" b="1" i="0">
+              <a:rPr sz="1200" b="1" i="0">
                 <a:solidFill>
                   <a:srgbClr val="465753"/>
                 </a:solidFill>
@@ -3588,9 +3590,9 @@
               <a:t>niva</a:t>
             </a:r>
             <a:r>
-              <a:rPr sz="1100" b="0" i="0">
-                <a:solidFill>
-                  <a:srgbClr val="92988E"/>
+              <a:rPr sz="1200" b="0" i="0">
+                <a:solidFill>
+                  <a:srgbClr val="465753"/>
                 </a:solidFill>
                 <a:latin typeface="Arial"/>
               </a:rPr>
@@ -3607,7 +3609,7 @@
         </p:nvSpPr>
         <p:spPr>
           <a:xfrm>
-            <a:off x="10774375" y="6455664"/>
+            <a:off x="10774375" y="6437376"/>
             <a:ext cx="914400" cy="365760"/>
           </a:xfrm>
           <a:prstGeom prst="rect">
@@ -3627,9 +3629,9 @@
               </a:lnSpc>
             </a:pPr>
             <a:r>
-              <a:rPr sz="1100" b="0" i="0">
-                <a:solidFill>
-                  <a:srgbClr val="92988E"/>
+              <a:rPr sz="1200" b="1" i="0">
+                <a:solidFill>
+                  <a:srgbClr val="465753"/>
                 </a:solidFill>
                 <a:latin typeface="Arial"/>
               </a:rPr>
@@ -3862,7 +3864,7 @@
         </p:nvSpPr>
         <p:spPr>
           <a:xfrm>
-            <a:off x="502920" y="6455664"/>
+            <a:off x="502920" y="6437376"/>
             <a:ext cx="5486400" cy="365760"/>
           </a:xfrm>
           <a:prstGeom prst="rect">
@@ -3882,7 +3884,7 @@
               </a:lnSpc>
             </a:pPr>
             <a:r>
-              <a:rPr sz="1100" b="1" i="0">
+              <a:rPr sz="1200" b="1" i="0">
                 <a:solidFill>
                   <a:srgbClr val="465753"/>
                 </a:solidFill>
@@ -3891,9 +3893,9 @@
               <a:t>niva</a:t>
             </a:r>
             <a:r>
-              <a:rPr sz="1100" b="0" i="0">
-                <a:solidFill>
-                  <a:srgbClr val="92988E"/>
+              <a:rPr sz="1200" b="0" i="0">
+                <a:solidFill>
+                  <a:srgbClr val="465753"/>
                 </a:solidFill>
                 <a:latin typeface="Arial"/>
               </a:rPr>
@@ -3910,7 +3912,7 @@
         </p:nvSpPr>
         <p:spPr>
           <a:xfrm>
-            <a:off x="10774375" y="6455664"/>
+            <a:off x="10774375" y="6437376"/>
             <a:ext cx="914400" cy="365760"/>
           </a:xfrm>
           <a:prstGeom prst="rect">
@@ -3930,9 +3932,9 @@
               </a:lnSpc>
             </a:pPr>
             <a:r>
-              <a:rPr sz="1100" b="0" i="0">
-                <a:solidFill>
-                  <a:srgbClr val="92988E"/>
+              <a:rPr sz="1200" b="1" i="0">
+                <a:solidFill>
+                  <a:srgbClr val="465753"/>
                 </a:solidFill>
                 <a:latin typeface="Arial"/>
               </a:rPr>
@@ -4165,7 +4167,7 @@
         </p:nvSpPr>
         <p:spPr>
           <a:xfrm>
-            <a:off x="502920" y="6455664"/>
+            <a:off x="502920" y="6437376"/>
             <a:ext cx="5486400" cy="365760"/>
           </a:xfrm>
           <a:prstGeom prst="rect">
@@ -4185,7 +4187,7 @@
               </a:lnSpc>
             </a:pPr>
             <a:r>
-              <a:rPr sz="1100" b="1" i="0">
+              <a:rPr sz="1200" b="1" i="0">
                 <a:solidFill>
                   <a:srgbClr val="465753"/>
                 </a:solidFill>
@@ -4194,9 +4196,9 @@
               <a:t>niva</a:t>
             </a:r>
             <a:r>
-              <a:rPr sz="1100" b="0" i="0">
-                <a:solidFill>
-                  <a:srgbClr val="92988E"/>
+              <a:rPr sz="1200" b="0" i="0">
+                <a:solidFill>
+                  <a:srgbClr val="465753"/>
                 </a:solidFill>
                 <a:latin typeface="Arial"/>
               </a:rPr>
@@ -4213,7 +4215,7 @@
         </p:nvSpPr>
         <p:spPr>
           <a:xfrm>
-            <a:off x="10774375" y="6455664"/>
+            <a:off x="10774375" y="6437376"/>
             <a:ext cx="914400" cy="365760"/>
           </a:xfrm>
           <a:prstGeom prst="rect">
@@ -4233,9 +4235,9 @@
               </a:lnSpc>
             </a:pPr>
             <a:r>
-              <a:rPr sz="1100" b="0" i="0">
-                <a:solidFill>
-                  <a:srgbClr val="92988E"/>
+              <a:rPr sz="1200" b="1" i="0">
+                <a:solidFill>
+                  <a:srgbClr val="465753"/>
                 </a:solidFill>
                 <a:latin typeface="Arial"/>
               </a:rPr>
@@ -4867,7 +4869,7 @@
         </p:nvSpPr>
         <p:spPr>
           <a:xfrm>
-            <a:off x="502920" y="6455664"/>
+            <a:off x="502920" y="6437376"/>
             <a:ext cx="5486400" cy="365760"/>
           </a:xfrm>
           <a:prstGeom prst="rect">
@@ -4887,7 +4889,7 @@
               </a:lnSpc>
             </a:pPr>
             <a:r>
-              <a:rPr sz="1100" b="1" i="0">
+              <a:rPr sz="1200" b="1" i="0">
                 <a:solidFill>
                   <a:srgbClr val="465753"/>
                 </a:solidFill>
@@ -4896,9 +4898,9 @@
               <a:t>niva</a:t>
             </a:r>
             <a:r>
-              <a:rPr sz="1100" b="0" i="0">
-                <a:solidFill>
-                  <a:srgbClr val="92988E"/>
+              <a:rPr sz="1200" b="0" i="0">
+                <a:solidFill>
+                  <a:srgbClr val="465753"/>
                 </a:solidFill>
                 <a:latin typeface="Arial"/>
               </a:rPr>
@@ -4915,7 +4917,7 @@
         </p:nvSpPr>
         <p:spPr>
           <a:xfrm>
-            <a:off x="10774375" y="6455664"/>
+            <a:off x="10774375" y="6437376"/>
             <a:ext cx="914400" cy="365760"/>
           </a:xfrm>
           <a:prstGeom prst="rect">
@@ -4935,9 +4937,9 @@
               </a:lnSpc>
             </a:pPr>
             <a:r>
-              <a:rPr sz="1100" b="0" i="0">
-                <a:solidFill>
-                  <a:srgbClr val="92988E"/>
+              <a:rPr sz="1200" b="1" i="0">
+                <a:solidFill>
+                  <a:srgbClr val="465753"/>
                 </a:solidFill>
                 <a:latin typeface="Arial"/>
               </a:rPr>
@@ -5514,7 +5516,7 @@
         </p:nvSpPr>
         <p:spPr>
           <a:xfrm>
-            <a:off x="502920" y="6455664"/>
+            <a:off x="502920" y="6437376"/>
             <a:ext cx="5486400" cy="365760"/>
           </a:xfrm>
           <a:prstGeom prst="rect">
@@ -5534,7 +5536,7 @@
               </a:lnSpc>
             </a:pPr>
             <a:r>
-              <a:rPr sz="1100" b="1" i="0">
+              <a:rPr sz="1200" b="1" i="0">
                 <a:solidFill>
                   <a:srgbClr val="465753"/>
                 </a:solidFill>
@@ -5543,9 +5545,9 @@
               <a:t>niva</a:t>
             </a:r>
             <a:r>
-              <a:rPr sz="1100" b="0" i="0">
-                <a:solidFill>
-                  <a:srgbClr val="92988E"/>
+              <a:rPr sz="1200" b="0" i="0">
+                <a:solidFill>
+                  <a:srgbClr val="465753"/>
                 </a:solidFill>
                 <a:latin typeface="Arial"/>
               </a:rPr>
@@ -5562,7 +5564,7 @@
         </p:nvSpPr>
         <p:spPr>
           <a:xfrm>
-            <a:off x="10774375" y="6455664"/>
+            <a:off x="10774375" y="6437376"/>
             <a:ext cx="914400" cy="365760"/>
           </a:xfrm>
           <a:prstGeom prst="rect">
@@ -5582,9 +5584,9 @@
               </a:lnSpc>
             </a:pPr>
             <a:r>
-              <a:rPr sz="1100" b="0" i="0">
-                <a:solidFill>
-                  <a:srgbClr val="92988E"/>
+              <a:rPr sz="1200" b="1" i="0">
+                <a:solidFill>
+                  <a:srgbClr val="465753"/>
                 </a:solidFill>
                 <a:latin typeface="Arial"/>
               </a:rPr>
@@ -6789,7 +6791,7 @@
         </p:nvSpPr>
         <p:spPr>
           <a:xfrm>
-            <a:off x="502920" y="6455664"/>
+            <a:off x="502920" y="6437376"/>
             <a:ext cx="5486400" cy="365760"/>
           </a:xfrm>
           <a:prstGeom prst="rect">
@@ -6809,7 +6811,7 @@
               </a:lnSpc>
             </a:pPr>
             <a:r>
-              <a:rPr sz="1100" b="1" i="0">
+              <a:rPr sz="1200" b="1" i="0">
                 <a:solidFill>
                   <a:srgbClr val="465753"/>
                 </a:solidFill>
@@ -6818,9 +6820,9 @@
               <a:t>niva</a:t>
             </a:r>
             <a:r>
-              <a:rPr sz="1100" b="0" i="0">
-                <a:solidFill>
-                  <a:srgbClr val="92988E"/>
+              <a:rPr sz="1200" b="0" i="0">
+                <a:solidFill>
+                  <a:srgbClr val="465753"/>
                 </a:solidFill>
                 <a:latin typeface="Arial"/>
               </a:rPr>
@@ -6837,7 +6839,7 @@
         </p:nvSpPr>
         <p:spPr>
           <a:xfrm>
-            <a:off x="10774375" y="6455664"/>
+            <a:off x="10774375" y="6437376"/>
             <a:ext cx="914400" cy="365760"/>
           </a:xfrm>
           <a:prstGeom prst="rect">
@@ -6857,9 +6859,9 @@
               </a:lnSpc>
             </a:pPr>
             <a:r>
-              <a:rPr sz="1100" b="0" i="0">
-                <a:solidFill>
-                  <a:srgbClr val="92988E"/>
+              <a:rPr sz="1200" b="1" i="0">
+                <a:solidFill>
+                  <a:srgbClr val="465753"/>
                 </a:solidFill>
                 <a:latin typeface="Arial"/>
               </a:rPr>
@@ -6902,6 +6904,2361 @@
         </p:nvSpPr>
         <p:spPr>
           <a:xfrm>
+            <a:off x="502920" y="566928"/>
+            <a:ext cx="109728" cy="566928"/>
+          </a:xfrm>
+          <a:prstGeom prst="rect">
+            <a:avLst/>
+          </a:prstGeom>
+          <a:solidFill>
+            <a:srgbClr val="465753"/>
+          </a:solidFill>
+          <a:ln>
+            <a:noFill/>
+          </a:ln>
+          <a:effectLst/>
+        </p:spPr>
+        <p:style>
+          <a:lnRef idx="1">
+            <a:schemeClr val="accent1"/>
+          </a:lnRef>
+          <a:fillRef idx="3">
+            <a:schemeClr val="accent1"/>
+          </a:fillRef>
+          <a:effectRef idx="2">
+            <a:schemeClr val="accent1"/>
+          </a:effectRef>
+          <a:fontRef idx="minor">
+            <a:schemeClr val="lt1"/>
+          </a:fontRef>
+        </p:style>
+        <p:txBody>
+          <a:bodyPr rtlCol="0" anchor="ctr"/>
+          <a:lstStyle/>
+          <a:p>
+            <a:pPr algn="ctr"/>
+          </a:p>
+        </p:txBody>
+      </p:sp>
+      <p:sp>
+        <p:nvSpPr>
+          <p:cNvPr id="3" name="TextBox 2"/>
+          <p:cNvSpPr txBox="1"/>
+          <p:nvPr/>
+        </p:nvSpPr>
+        <p:spPr>
+          <a:xfrm>
+            <a:off x="731520" y="457200"/>
+            <a:ext cx="10789920" cy="320040"/>
+          </a:xfrm>
+          <a:prstGeom prst="rect">
+            <a:avLst/>
+          </a:prstGeom>
+          <a:noFill/>
+        </p:spPr>
+        <p:txBody>
+          <a:bodyPr wrap="square" anchor="t">
+            <a:spAutoFit/>
+          </a:bodyPr>
+          <a:lstStyle/>
+          <a:p>
+            <a:pPr algn="l">
+              <a:lnSpc>
+                <a:spcPct val="100000"/>
+              </a:lnSpc>
+            </a:pPr>
+            <a:r>
+              <a:rPr sz="1250" b="1" i="0">
+                <a:solidFill>
+                  <a:srgbClr val="C1B49B"/>
+                </a:solidFill>
+                <a:latin typeface="Arial"/>
+              </a:rPr>
+              <a:t>STATUS · BUILT AND TESTED</a:t>
+            </a:r>
+          </a:p>
+        </p:txBody>
+      </p:sp>
+      <p:sp>
+        <p:nvSpPr>
+          <p:cNvPr id="4" name="TextBox 3"/>
+          <p:cNvSpPr txBox="1"/>
+          <p:nvPr/>
+        </p:nvSpPr>
+        <p:spPr>
+          <a:xfrm>
+            <a:off x="731520" y="749808"/>
+            <a:ext cx="10881360" cy="822960"/>
+          </a:xfrm>
+          <a:prstGeom prst="rect">
+            <a:avLst/>
+          </a:prstGeom>
+          <a:noFill/>
+        </p:spPr>
+        <p:txBody>
+          <a:bodyPr wrap="square" anchor="t">
+            <a:spAutoFit/>
+          </a:bodyPr>
+          <a:lstStyle/>
+          <a:p>
+            <a:pPr algn="l">
+              <a:lnSpc>
+                <a:spcPct val="100000"/>
+              </a:lnSpc>
+            </a:pPr>
+            <a:r>
+              <a:rPr sz="3000" b="1" i="0">
+                <a:solidFill>
+                  <a:srgbClr val="28323B"/>
+                </a:solidFill>
+                <a:latin typeface="Arial"/>
+              </a:rPr>
+              <a:t>What's working today</a:t>
+            </a:r>
+          </a:p>
+        </p:txBody>
+      </p:sp>
+      <p:sp>
+        <p:nvSpPr>
+          <p:cNvPr id="5" name="TextBox 4"/>
+          <p:cNvSpPr txBox="1"/>
+          <p:nvPr/>
+        </p:nvSpPr>
+        <p:spPr>
+          <a:xfrm>
+            <a:off x="777240" y="1417320"/>
+            <a:ext cx="10607040" cy="457200"/>
+          </a:xfrm>
+          <a:prstGeom prst="rect">
+            <a:avLst/>
+          </a:prstGeom>
+          <a:noFill/>
+        </p:spPr>
+        <p:txBody>
+          <a:bodyPr wrap="square" anchor="t">
+            <a:spAutoFit/>
+          </a:bodyPr>
+          <a:lstStyle/>
+          <a:p>
+            <a:pPr algn="l">
+              <a:lnSpc>
+                <a:spcPct val="100000"/>
+              </a:lnSpc>
+            </a:pPr>
+            <a:r>
+              <a:rPr sz="1700" b="0" i="0">
+                <a:solidFill>
+                  <a:srgbClr val="6B7B6F"/>
+                </a:solidFill>
+                <a:latin typeface="Arial"/>
+              </a:rPr>
+              <a:t>niva is pre-release (v0.1) — but the core already runs real analysis end-to-end, on QGIS's own algorithms:</a:t>
+            </a:r>
+          </a:p>
+        </p:txBody>
+      </p:sp>
+      <p:sp>
+        <p:nvSpPr>
+          <p:cNvPr id="6" name="Rectangle 5"/>
+          <p:cNvSpPr/>
+          <p:nvPr/>
+        </p:nvSpPr>
+        <p:spPr>
+          <a:xfrm>
+            <a:off x="678027" y="2011680"/>
+            <a:ext cx="5303520" cy="2057400"/>
+          </a:xfrm>
+          <a:prstGeom prst="rect">
+            <a:avLst/>
+          </a:prstGeom>
+          <a:solidFill>
+            <a:srgbClr val="EEF1EC"/>
+          </a:solidFill>
+          <a:ln>
+            <a:noFill/>
+          </a:ln>
+          <a:effectLst/>
+        </p:spPr>
+        <p:style>
+          <a:lnRef idx="1">
+            <a:schemeClr val="accent1"/>
+          </a:lnRef>
+          <a:fillRef idx="3">
+            <a:schemeClr val="accent1"/>
+          </a:fillRef>
+          <a:effectRef idx="2">
+            <a:schemeClr val="accent1"/>
+          </a:effectRef>
+          <a:fontRef idx="minor">
+            <a:schemeClr val="lt1"/>
+          </a:fontRef>
+        </p:style>
+        <p:txBody>
+          <a:bodyPr rtlCol="0" anchor="ctr"/>
+          <a:lstStyle/>
+          <a:p>
+            <a:pPr algn="ctr"/>
+          </a:p>
+        </p:txBody>
+      </p:sp>
+      <p:sp>
+        <p:nvSpPr>
+          <p:cNvPr id="7" name="Rectangle 6"/>
+          <p:cNvSpPr/>
+          <p:nvPr/>
+        </p:nvSpPr>
+        <p:spPr>
+          <a:xfrm>
+            <a:off x="678027" y="2011680"/>
+            <a:ext cx="5303520" cy="146304"/>
+          </a:xfrm>
+          <a:prstGeom prst="rect">
+            <a:avLst/>
+          </a:prstGeom>
+          <a:solidFill>
+            <a:srgbClr val="465753"/>
+          </a:solidFill>
+          <a:ln>
+            <a:noFill/>
+          </a:ln>
+          <a:effectLst/>
+        </p:spPr>
+        <p:style>
+          <a:lnRef idx="1">
+            <a:schemeClr val="accent1"/>
+          </a:lnRef>
+          <a:fillRef idx="3">
+            <a:schemeClr val="accent1"/>
+          </a:fillRef>
+          <a:effectRef idx="2">
+            <a:schemeClr val="accent1"/>
+          </a:effectRef>
+          <a:fontRef idx="minor">
+            <a:schemeClr val="lt1"/>
+          </a:fontRef>
+        </p:style>
+        <p:txBody>
+          <a:bodyPr rtlCol="0" anchor="ctr"/>
+          <a:lstStyle/>
+          <a:p>
+            <a:pPr algn="ctr"/>
+          </a:p>
+        </p:txBody>
+      </p:sp>
+      <p:sp>
+        <p:nvSpPr>
+          <p:cNvPr id="8" name="TextBox 7"/>
+          <p:cNvSpPr txBox="1"/>
+          <p:nvPr/>
+        </p:nvSpPr>
+        <p:spPr>
+          <a:xfrm>
+            <a:off x="952347" y="2286000"/>
+            <a:ext cx="4754880" cy="365760"/>
+          </a:xfrm>
+          <a:prstGeom prst="rect">
+            <a:avLst/>
+          </a:prstGeom>
+          <a:noFill/>
+        </p:spPr>
+        <p:txBody>
+          <a:bodyPr wrap="square" anchor="t">
+            <a:spAutoFit/>
+          </a:bodyPr>
+          <a:lstStyle/>
+          <a:p>
+            <a:pPr algn="l">
+              <a:lnSpc>
+                <a:spcPct val="100000"/>
+              </a:lnSpc>
+            </a:pPr>
+            <a:r>
+              <a:rPr sz="1700" b="1" i="0">
+                <a:solidFill>
+                  <a:srgbClr val="465753"/>
+                </a:solidFill>
+                <a:latin typeface="Arial"/>
+              </a:rPr>
+              <a:t>Grammar &amp; engine</a:t>
+            </a:r>
+          </a:p>
+        </p:txBody>
+      </p:sp>
+      <p:sp>
+        <p:nvSpPr>
+          <p:cNvPr id="9" name="TextBox 8"/>
+          <p:cNvSpPr txBox="1"/>
+          <p:nvPr/>
+        </p:nvSpPr>
+        <p:spPr>
+          <a:xfrm>
+            <a:off x="952347" y="2761488"/>
+            <a:ext cx="4800600" cy="1216152"/>
+          </a:xfrm>
+          <a:prstGeom prst="rect">
+            <a:avLst/>
+          </a:prstGeom>
+          <a:noFill/>
+        </p:spPr>
+        <p:txBody>
+          <a:bodyPr wrap="square" anchor="t">
+            <a:spAutoFit/>
+          </a:bodyPr>
+          <a:lstStyle/>
+          <a:p>
+            <a:pPr algn="l">
+              <a:lnSpc>
+                <a:spcPct val="130000"/>
+              </a:lnSpc>
+            </a:pPr>
+            <a:r>
+              <a:rPr sz="1400" b="1" i="0">
+                <a:solidFill>
+                  <a:srgbClr val="465753"/>
+                </a:solidFill>
+                <a:latin typeface="Arial"/>
+              </a:rPr>
+              <a:t>✓  </a:t>
+            </a:r>
+            <a:r>
+              <a:rPr sz="1400" b="0" i="0">
+                <a:solidFill>
+                  <a:srgbClr val="6B7B6F"/>
+                </a:solidFill>
+                <a:latin typeface="Arial"/>
+              </a:rPr>
+              <a:t>Readable lexer + parser → pipeline stages</a:t>
+            </a:r>
+          </a:p>
+          <a:p>
+            <a:pPr algn="l">
+              <a:lnSpc>
+                <a:spcPct val="130000"/>
+              </a:lnSpc>
+            </a:pPr>
+            <a:r>
+              <a:rPr sz="1400" b="1" i="0">
+                <a:solidFill>
+                  <a:srgbClr val="465753"/>
+                </a:solidFill>
+                <a:latin typeface="Arial"/>
+              </a:rPr>
+              <a:t>✓  </a:t>
+            </a:r>
+            <a:r>
+              <a:rPr sz="1400" b="0" i="0">
+                <a:solidFill>
+                  <a:srgbClr val="6B7B6F"/>
+                </a:solidFill>
+                <a:latin typeface="Arial"/>
+              </a:rPr>
+              <a:t>Pipe-chaining engine: layer handles, results</a:t>
+            </a:r>
+          </a:p>
+          <a:p>
+            <a:pPr algn="l">
+              <a:lnSpc>
+                <a:spcPct val="130000"/>
+              </a:lnSpc>
+            </a:pPr>
+            <a:r>
+              <a:rPr sz="1400" b="1" i="0">
+                <a:solidFill>
+                  <a:srgbClr val="465753"/>
+                </a:solidFill>
+                <a:latin typeface="Arial"/>
+              </a:rPr>
+              <a:t>✓  </a:t>
+            </a:r>
+            <a:r>
+              <a:rPr sz="1400" b="0" i="0">
+                <a:solidFill>
+                  <a:srgbClr val="6B7B6F"/>
+                </a:solidFill>
+                <a:latin typeface="Arial"/>
+              </a:rPr>
+              <a:t>PyQGIS backend — runs real geoprocessing</a:t>
+            </a:r>
+          </a:p>
+        </p:txBody>
+      </p:sp>
+      <p:sp>
+        <p:nvSpPr>
+          <p:cNvPr id="10" name="Rectangle 9"/>
+          <p:cNvSpPr/>
+          <p:nvPr/>
+        </p:nvSpPr>
+        <p:spPr>
+          <a:xfrm>
+            <a:off x="6210147" y="2011680"/>
+            <a:ext cx="5303520" cy="2057400"/>
+          </a:xfrm>
+          <a:prstGeom prst="rect">
+            <a:avLst/>
+          </a:prstGeom>
+          <a:solidFill>
+            <a:srgbClr val="EEF1EC"/>
+          </a:solidFill>
+          <a:ln>
+            <a:noFill/>
+          </a:ln>
+          <a:effectLst/>
+        </p:spPr>
+        <p:style>
+          <a:lnRef idx="1">
+            <a:schemeClr val="accent1"/>
+          </a:lnRef>
+          <a:fillRef idx="3">
+            <a:schemeClr val="accent1"/>
+          </a:fillRef>
+          <a:effectRef idx="2">
+            <a:schemeClr val="accent1"/>
+          </a:effectRef>
+          <a:fontRef idx="minor">
+            <a:schemeClr val="lt1"/>
+          </a:fontRef>
+        </p:style>
+        <p:txBody>
+          <a:bodyPr rtlCol="0" anchor="ctr"/>
+          <a:lstStyle/>
+          <a:p>
+            <a:pPr algn="ctr"/>
+          </a:p>
+        </p:txBody>
+      </p:sp>
+      <p:sp>
+        <p:nvSpPr>
+          <p:cNvPr id="11" name="Rectangle 10"/>
+          <p:cNvSpPr/>
+          <p:nvPr/>
+        </p:nvSpPr>
+        <p:spPr>
+          <a:xfrm>
+            <a:off x="6210147" y="2011680"/>
+            <a:ext cx="5303520" cy="146304"/>
+          </a:xfrm>
+          <a:prstGeom prst="rect">
+            <a:avLst/>
+          </a:prstGeom>
+          <a:solidFill>
+            <a:srgbClr val="C1B49B"/>
+          </a:solidFill>
+          <a:ln>
+            <a:noFill/>
+          </a:ln>
+          <a:effectLst/>
+        </p:spPr>
+        <p:style>
+          <a:lnRef idx="1">
+            <a:schemeClr val="accent1"/>
+          </a:lnRef>
+          <a:fillRef idx="3">
+            <a:schemeClr val="accent1"/>
+          </a:fillRef>
+          <a:effectRef idx="2">
+            <a:schemeClr val="accent1"/>
+          </a:effectRef>
+          <a:fontRef idx="minor">
+            <a:schemeClr val="lt1"/>
+          </a:fontRef>
+        </p:style>
+        <p:txBody>
+          <a:bodyPr rtlCol="0" anchor="ctr"/>
+          <a:lstStyle/>
+          <a:p>
+            <a:pPr algn="ctr"/>
+          </a:p>
+        </p:txBody>
+      </p:sp>
+      <p:sp>
+        <p:nvSpPr>
+          <p:cNvPr id="12" name="TextBox 11"/>
+          <p:cNvSpPr txBox="1"/>
+          <p:nvPr/>
+        </p:nvSpPr>
+        <p:spPr>
+          <a:xfrm>
+            <a:off x="6484467" y="2286000"/>
+            <a:ext cx="4754880" cy="365760"/>
+          </a:xfrm>
+          <a:prstGeom prst="rect">
+            <a:avLst/>
+          </a:prstGeom>
+          <a:noFill/>
+        </p:spPr>
+        <p:txBody>
+          <a:bodyPr wrap="square" anchor="t">
+            <a:spAutoFit/>
+          </a:bodyPr>
+          <a:lstStyle/>
+          <a:p>
+            <a:pPr algn="l">
+              <a:lnSpc>
+                <a:spcPct val="100000"/>
+              </a:lnSpc>
+            </a:pPr>
+            <a:r>
+              <a:rPr sz="1700" b="1" i="0">
+                <a:solidFill>
+                  <a:srgbClr val="465753"/>
+                </a:solidFill>
+                <a:latin typeface="Arial"/>
+              </a:rPr>
+              <a:t>Verb coverage</a:t>
+            </a:r>
+          </a:p>
+        </p:txBody>
+      </p:sp>
+      <p:sp>
+        <p:nvSpPr>
+          <p:cNvPr id="13" name="TextBox 12"/>
+          <p:cNvSpPr txBox="1"/>
+          <p:nvPr/>
+        </p:nvSpPr>
+        <p:spPr>
+          <a:xfrm>
+            <a:off x="6484467" y="2761488"/>
+            <a:ext cx="4800600" cy="1216152"/>
+          </a:xfrm>
+          <a:prstGeom prst="rect">
+            <a:avLst/>
+          </a:prstGeom>
+          <a:noFill/>
+        </p:spPr>
+        <p:txBody>
+          <a:bodyPr wrap="square" anchor="t">
+            <a:spAutoFit/>
+          </a:bodyPr>
+          <a:lstStyle/>
+          <a:p>
+            <a:pPr algn="l">
+              <a:lnSpc>
+                <a:spcPct val="130000"/>
+              </a:lnSpc>
+            </a:pPr>
+            <a:r>
+              <a:rPr sz="1400" b="1" i="0">
+                <a:solidFill>
+                  <a:srgbClr val="465753"/>
+                </a:solidFill>
+                <a:latin typeface="Arial"/>
+              </a:rPr>
+              <a:t>✓  </a:t>
+            </a:r>
+            <a:r>
+              <a:rPr sz="1400" b="0" i="0">
+                <a:solidFill>
+                  <a:srgbClr val="6B7B6F"/>
+                </a:solidFill>
+                <a:latin typeface="Arial"/>
+              </a:rPr>
+              <a:t>~40-verb registry (Tier 1 + Tier 2 aliases)</a:t>
+            </a:r>
+          </a:p>
+          <a:p>
+            <a:pPr algn="l">
+              <a:lnSpc>
+                <a:spcPct val="130000"/>
+              </a:lnSpc>
+            </a:pPr>
+            <a:r>
+              <a:rPr sz="1400" b="1" i="0">
+                <a:solidFill>
+                  <a:srgbClr val="465753"/>
+                </a:solidFill>
+                <a:latin typeface="Arial"/>
+              </a:rPr>
+              <a:t>✓  </a:t>
+            </a:r>
+            <a:r>
+              <a:rPr sz="1400" b="0" i="0">
+                <a:solidFill>
+                  <a:srgbClr val="6B7B6F"/>
+                </a:solidFill>
+                <a:latin typeface="Arial"/>
+              </a:rPr>
+              <a:t>9 core built-ins (load · save · filter · compute …)</a:t>
+            </a:r>
+          </a:p>
+          <a:p>
+            <a:pPr algn="l">
+              <a:lnSpc>
+                <a:spcPct val="130000"/>
+              </a:lnSpc>
+            </a:pPr>
+            <a:r>
+              <a:rPr sz="1400" b="1" i="0">
+                <a:solidFill>
+                  <a:srgbClr val="465753"/>
+                </a:solidFill>
+                <a:latin typeface="Arial"/>
+              </a:rPr>
+              <a:t>✓  </a:t>
+            </a:r>
+            <a:r>
+              <a:rPr sz="1400" b="0" i="0">
+                <a:solidFill>
+                  <a:srgbClr val="6B7B6F"/>
+                </a:solidFill>
+                <a:latin typeface="Arial"/>
+              </a:rPr>
+              <a:t>sql read passthrough (SELECT → layer)</a:t>
+            </a:r>
+          </a:p>
+          <a:p>
+            <a:pPr algn="l">
+              <a:lnSpc>
+                <a:spcPct val="130000"/>
+              </a:lnSpc>
+            </a:pPr>
+            <a:r>
+              <a:rPr sz="1400" b="1" i="0">
+                <a:solidFill>
+                  <a:srgbClr val="465753"/>
+                </a:solidFill>
+                <a:latin typeface="Arial"/>
+              </a:rPr>
+              <a:t>✓  </a:t>
+            </a:r>
+            <a:r>
+              <a:rPr sz="1400" b="0" i="0">
+                <a:solidFill>
+                  <a:srgbClr val="6B7B6F"/>
+                </a:solidFill>
+                <a:latin typeface="Arial"/>
+              </a:rPr>
+              <a:t>run — reach ANY QGIS algorithm</a:t>
+            </a:r>
+          </a:p>
+        </p:txBody>
+      </p:sp>
+      <p:sp>
+        <p:nvSpPr>
+          <p:cNvPr id="14" name="Rectangle 13"/>
+          <p:cNvSpPr/>
+          <p:nvPr/>
+        </p:nvSpPr>
+        <p:spPr>
+          <a:xfrm>
+            <a:off x="678027" y="4251960"/>
+            <a:ext cx="5303520" cy="2057400"/>
+          </a:xfrm>
+          <a:prstGeom prst="rect">
+            <a:avLst/>
+          </a:prstGeom>
+          <a:solidFill>
+            <a:srgbClr val="EEF1EC"/>
+          </a:solidFill>
+          <a:ln>
+            <a:noFill/>
+          </a:ln>
+          <a:effectLst/>
+        </p:spPr>
+        <p:style>
+          <a:lnRef idx="1">
+            <a:schemeClr val="accent1"/>
+          </a:lnRef>
+          <a:fillRef idx="3">
+            <a:schemeClr val="accent1"/>
+          </a:fillRef>
+          <a:effectRef idx="2">
+            <a:schemeClr val="accent1"/>
+          </a:effectRef>
+          <a:fontRef idx="minor">
+            <a:schemeClr val="lt1"/>
+          </a:fontRef>
+        </p:style>
+        <p:txBody>
+          <a:bodyPr rtlCol="0" anchor="ctr"/>
+          <a:lstStyle/>
+          <a:p>
+            <a:pPr algn="ctr"/>
+          </a:p>
+        </p:txBody>
+      </p:sp>
+      <p:sp>
+        <p:nvSpPr>
+          <p:cNvPr id="15" name="Rectangle 14"/>
+          <p:cNvSpPr/>
+          <p:nvPr/>
+        </p:nvSpPr>
+        <p:spPr>
+          <a:xfrm>
+            <a:off x="678027" y="4251960"/>
+            <a:ext cx="5303520" cy="146304"/>
+          </a:xfrm>
+          <a:prstGeom prst="rect">
+            <a:avLst/>
+          </a:prstGeom>
+          <a:solidFill>
+            <a:srgbClr val="465753"/>
+          </a:solidFill>
+          <a:ln>
+            <a:noFill/>
+          </a:ln>
+          <a:effectLst/>
+        </p:spPr>
+        <p:style>
+          <a:lnRef idx="1">
+            <a:schemeClr val="accent1"/>
+          </a:lnRef>
+          <a:fillRef idx="3">
+            <a:schemeClr val="accent1"/>
+          </a:fillRef>
+          <a:effectRef idx="2">
+            <a:schemeClr val="accent1"/>
+          </a:effectRef>
+          <a:fontRef idx="minor">
+            <a:schemeClr val="lt1"/>
+          </a:fontRef>
+        </p:style>
+        <p:txBody>
+          <a:bodyPr rtlCol="0" anchor="ctr"/>
+          <a:lstStyle/>
+          <a:p>
+            <a:pPr algn="ctr"/>
+          </a:p>
+        </p:txBody>
+      </p:sp>
+      <p:sp>
+        <p:nvSpPr>
+          <p:cNvPr id="16" name="TextBox 15"/>
+          <p:cNvSpPr txBox="1"/>
+          <p:nvPr/>
+        </p:nvSpPr>
+        <p:spPr>
+          <a:xfrm>
+            <a:off x="952347" y="4526280"/>
+            <a:ext cx="4754880" cy="365760"/>
+          </a:xfrm>
+          <a:prstGeom prst="rect">
+            <a:avLst/>
+          </a:prstGeom>
+          <a:noFill/>
+        </p:spPr>
+        <p:txBody>
+          <a:bodyPr wrap="square" anchor="t">
+            <a:spAutoFit/>
+          </a:bodyPr>
+          <a:lstStyle/>
+          <a:p>
+            <a:pPr algn="l">
+              <a:lnSpc>
+                <a:spcPct val="100000"/>
+              </a:lnSpc>
+            </a:pPr>
+            <a:r>
+              <a:rPr sz="1700" b="1" i="0">
+                <a:solidFill>
+                  <a:srgbClr val="465753"/>
+                </a:solidFill>
+                <a:latin typeface="Arial"/>
+              </a:rPr>
+              <a:t>Provenance &amp; quality</a:t>
+            </a:r>
+          </a:p>
+        </p:txBody>
+      </p:sp>
+      <p:sp>
+        <p:nvSpPr>
+          <p:cNvPr id="17" name="TextBox 16"/>
+          <p:cNvSpPr txBox="1"/>
+          <p:nvPr/>
+        </p:nvSpPr>
+        <p:spPr>
+          <a:xfrm>
+            <a:off x="952347" y="5001768"/>
+            <a:ext cx="4800600" cy="1216152"/>
+          </a:xfrm>
+          <a:prstGeom prst="rect">
+            <a:avLst/>
+          </a:prstGeom>
+          <a:noFill/>
+        </p:spPr>
+        <p:txBody>
+          <a:bodyPr wrap="square" anchor="t">
+            <a:spAutoFit/>
+          </a:bodyPr>
+          <a:lstStyle/>
+          <a:p>
+            <a:pPr algn="l">
+              <a:lnSpc>
+                <a:spcPct val="130000"/>
+              </a:lnSpc>
+            </a:pPr>
+            <a:r>
+              <a:rPr sz="1400" b="1" i="0">
+                <a:solidFill>
+                  <a:srgbClr val="465753"/>
+                </a:solidFill>
+                <a:latin typeface="Arial"/>
+              </a:rPr>
+              <a:t>✓  </a:t>
+            </a:r>
+            <a:r>
+              <a:rPr sz="1400" b="0" i="0">
+                <a:solidFill>
+                  <a:srgbClr val="6B7B6F"/>
+                </a:solidFill>
+                <a:latin typeface="Arial"/>
+              </a:rPr>
+              <a:t>Operation log / run journal — auto-recorded</a:t>
+            </a:r>
+          </a:p>
+          <a:p>
+            <a:pPr algn="l">
+              <a:lnSpc>
+                <a:spcPct val="130000"/>
+              </a:lnSpc>
+            </a:pPr>
+            <a:r>
+              <a:rPr sz="1400" b="1" i="0">
+                <a:solidFill>
+                  <a:srgbClr val="465753"/>
+                </a:solidFill>
+                <a:latin typeface="Arial"/>
+              </a:rPr>
+              <a:t>✓  </a:t>
+            </a:r>
+            <a:r>
+              <a:rPr sz="1400" b="0" i="0">
+                <a:solidFill>
+                  <a:srgbClr val="6B7B6F"/>
+                </a:solidFill>
+                <a:latin typeface="Arial"/>
+              </a:rPr>
+              <a:t>assess — profile inputs before you trust them</a:t>
+            </a:r>
+          </a:p>
+        </p:txBody>
+      </p:sp>
+      <p:sp>
+        <p:nvSpPr>
+          <p:cNvPr id="18" name="Rectangle 17"/>
+          <p:cNvSpPr/>
+          <p:nvPr/>
+        </p:nvSpPr>
+        <p:spPr>
+          <a:xfrm>
+            <a:off x="6210147" y="4251960"/>
+            <a:ext cx="5303520" cy="2057400"/>
+          </a:xfrm>
+          <a:prstGeom prst="rect">
+            <a:avLst/>
+          </a:prstGeom>
+          <a:solidFill>
+            <a:srgbClr val="EEF1EC"/>
+          </a:solidFill>
+          <a:ln>
+            <a:noFill/>
+          </a:ln>
+          <a:effectLst/>
+        </p:spPr>
+        <p:style>
+          <a:lnRef idx="1">
+            <a:schemeClr val="accent1"/>
+          </a:lnRef>
+          <a:fillRef idx="3">
+            <a:schemeClr val="accent1"/>
+          </a:fillRef>
+          <a:effectRef idx="2">
+            <a:schemeClr val="accent1"/>
+          </a:effectRef>
+          <a:fontRef idx="minor">
+            <a:schemeClr val="lt1"/>
+          </a:fontRef>
+        </p:style>
+        <p:txBody>
+          <a:bodyPr rtlCol="0" anchor="ctr"/>
+          <a:lstStyle/>
+          <a:p>
+            <a:pPr algn="ctr"/>
+          </a:p>
+        </p:txBody>
+      </p:sp>
+      <p:sp>
+        <p:nvSpPr>
+          <p:cNvPr id="19" name="Rectangle 18"/>
+          <p:cNvSpPr/>
+          <p:nvPr/>
+        </p:nvSpPr>
+        <p:spPr>
+          <a:xfrm>
+            <a:off x="6210147" y="4251960"/>
+            <a:ext cx="5303520" cy="146304"/>
+          </a:xfrm>
+          <a:prstGeom prst="rect">
+            <a:avLst/>
+          </a:prstGeom>
+          <a:solidFill>
+            <a:srgbClr val="C1B49B"/>
+          </a:solidFill>
+          <a:ln>
+            <a:noFill/>
+          </a:ln>
+          <a:effectLst/>
+        </p:spPr>
+        <p:style>
+          <a:lnRef idx="1">
+            <a:schemeClr val="accent1"/>
+          </a:lnRef>
+          <a:fillRef idx="3">
+            <a:schemeClr val="accent1"/>
+          </a:fillRef>
+          <a:effectRef idx="2">
+            <a:schemeClr val="accent1"/>
+          </a:effectRef>
+          <a:fontRef idx="minor">
+            <a:schemeClr val="lt1"/>
+          </a:fontRef>
+        </p:style>
+        <p:txBody>
+          <a:bodyPr rtlCol="0" anchor="ctr"/>
+          <a:lstStyle/>
+          <a:p>
+            <a:pPr algn="ctr"/>
+          </a:p>
+        </p:txBody>
+      </p:sp>
+      <p:sp>
+        <p:nvSpPr>
+          <p:cNvPr id="20" name="TextBox 19"/>
+          <p:cNvSpPr txBox="1"/>
+          <p:nvPr/>
+        </p:nvSpPr>
+        <p:spPr>
+          <a:xfrm>
+            <a:off x="6484467" y="4526280"/>
+            <a:ext cx="4754880" cy="365760"/>
+          </a:xfrm>
+          <a:prstGeom prst="rect">
+            <a:avLst/>
+          </a:prstGeom>
+          <a:noFill/>
+        </p:spPr>
+        <p:txBody>
+          <a:bodyPr wrap="square" anchor="t">
+            <a:spAutoFit/>
+          </a:bodyPr>
+          <a:lstStyle/>
+          <a:p>
+            <a:pPr algn="l">
+              <a:lnSpc>
+                <a:spcPct val="100000"/>
+              </a:lnSpc>
+            </a:pPr>
+            <a:r>
+              <a:rPr sz="1700" b="1" i="0">
+                <a:solidFill>
+                  <a:srgbClr val="465753"/>
+                </a:solidFill>
+                <a:latin typeface="Arial"/>
+              </a:rPr>
+              <a:t>Composition &amp; delivery</a:t>
+            </a:r>
+          </a:p>
+        </p:txBody>
+      </p:sp>
+      <p:sp>
+        <p:nvSpPr>
+          <p:cNvPr id="21" name="TextBox 20"/>
+          <p:cNvSpPr txBox="1"/>
+          <p:nvPr/>
+        </p:nvSpPr>
+        <p:spPr>
+          <a:xfrm>
+            <a:off x="6484467" y="5001768"/>
+            <a:ext cx="4800600" cy="1216152"/>
+          </a:xfrm>
+          <a:prstGeom prst="rect">
+            <a:avLst/>
+          </a:prstGeom>
+          <a:noFill/>
+        </p:spPr>
+        <p:txBody>
+          <a:bodyPr wrap="square" anchor="t">
+            <a:spAutoFit/>
+          </a:bodyPr>
+          <a:lstStyle/>
+          <a:p>
+            <a:pPr algn="l">
+              <a:lnSpc>
+                <a:spcPct val="130000"/>
+              </a:lnSpc>
+            </a:pPr>
+            <a:r>
+              <a:rPr sz="1400" b="1" i="0">
+                <a:solidFill>
+                  <a:srgbClr val="465753"/>
+                </a:solidFill>
+                <a:latin typeface="Arial"/>
+              </a:rPr>
+              <a:t>✓  </a:t>
+            </a:r>
+            <a:r>
+              <a:rPr sz="1400" b="0" i="0">
+                <a:solidFill>
+                  <a:srgbClr val="6B7B6F"/>
+                </a:solidFill>
+                <a:latin typeface="Arial"/>
+              </a:rPr>
+              <a:t>call — compose flows across files (cycle-safe)</a:t>
+            </a:r>
+          </a:p>
+          <a:p>
+            <a:pPr algn="l">
+              <a:lnSpc>
+                <a:spcPct val="130000"/>
+              </a:lnSpc>
+            </a:pPr>
+            <a:r>
+              <a:rPr sz="1400" b="1" i="0">
+                <a:solidFill>
+                  <a:srgbClr val="465753"/>
+                </a:solidFill>
+                <a:latin typeface="Arial"/>
+              </a:rPr>
+              <a:t>✓  </a:t>
+            </a:r>
+            <a:r>
+              <a:rPr sz="1400" b="0" i="0">
+                <a:solidFill>
+                  <a:srgbClr val="6B7B6F"/>
+                </a:solidFill>
+                <a:latin typeface="Arial"/>
+              </a:rPr>
+              <a:t>CLI + Python / Marimo API (--explain, --dry-run)</a:t>
+            </a:r>
+          </a:p>
+          <a:p>
+            <a:pPr algn="l">
+              <a:lnSpc>
+                <a:spcPct val="130000"/>
+              </a:lnSpc>
+            </a:pPr>
+            <a:r>
+              <a:rPr sz="1400" b="1" i="0">
+                <a:solidFill>
+                  <a:srgbClr val="465753"/>
+                </a:solidFill>
+                <a:latin typeface="Arial"/>
+              </a:rPr>
+              <a:t>✓  </a:t>
+            </a:r>
+            <a:r>
+              <a:rPr sz="1400" b="0" i="0">
+                <a:solidFill>
+                  <a:srgbClr val="6B7B6F"/>
+                </a:solidFill>
+                <a:latin typeface="Arial"/>
+              </a:rPr>
+              <a:t>80 tests passing under QGIS · headless CI</a:t>
+            </a:r>
+          </a:p>
+        </p:txBody>
+      </p:sp>
+      <p:sp>
+        <p:nvSpPr>
+          <p:cNvPr id="22" name="Rectangle 21"/>
+          <p:cNvSpPr/>
+          <p:nvPr/>
+        </p:nvSpPr>
+        <p:spPr>
+          <a:xfrm>
+            <a:off x="0" y="6565392"/>
+            <a:ext cx="12191695" cy="54864"/>
+          </a:xfrm>
+          <a:prstGeom prst="rect">
+            <a:avLst/>
+          </a:prstGeom>
+          <a:solidFill>
+            <a:srgbClr val="C1B49B"/>
+          </a:solidFill>
+          <a:ln>
+            <a:noFill/>
+          </a:ln>
+          <a:effectLst/>
+        </p:spPr>
+        <p:style>
+          <a:lnRef idx="1">
+            <a:schemeClr val="accent1"/>
+          </a:lnRef>
+          <a:fillRef idx="3">
+            <a:schemeClr val="accent1"/>
+          </a:fillRef>
+          <a:effectRef idx="2">
+            <a:schemeClr val="accent1"/>
+          </a:effectRef>
+          <a:fontRef idx="minor">
+            <a:schemeClr val="lt1"/>
+          </a:fontRef>
+        </p:style>
+        <p:txBody>
+          <a:bodyPr rtlCol="0" anchor="ctr"/>
+          <a:lstStyle/>
+          <a:p>
+            <a:pPr algn="ctr"/>
+          </a:p>
+        </p:txBody>
+      </p:sp>
+      <p:sp>
+        <p:nvSpPr>
+          <p:cNvPr id="23" name="TextBox 22"/>
+          <p:cNvSpPr txBox="1"/>
+          <p:nvPr/>
+        </p:nvSpPr>
+        <p:spPr>
+          <a:xfrm>
+            <a:off x="502920" y="6437376"/>
+            <a:ext cx="5486400" cy="365760"/>
+          </a:xfrm>
+          <a:prstGeom prst="rect">
+            <a:avLst/>
+          </a:prstGeom>
+          <a:noFill/>
+        </p:spPr>
+        <p:txBody>
+          <a:bodyPr wrap="square" anchor="t">
+            <a:spAutoFit/>
+          </a:bodyPr>
+          <a:lstStyle/>
+          <a:p>
+            <a:pPr algn="l">
+              <a:lnSpc>
+                <a:spcPct val="100000"/>
+              </a:lnSpc>
+            </a:pPr>
+            <a:r>
+              <a:rPr sz="1200" b="1" i="0">
+                <a:solidFill>
+                  <a:srgbClr val="465753"/>
+                </a:solidFill>
+                <a:latin typeface="Arial"/>
+              </a:rPr>
+              <a:t>niva</a:t>
+            </a:r>
+            <a:r>
+              <a:rPr sz="1200" b="0" i="0">
+                <a:solidFill>
+                  <a:srgbClr val="465753"/>
+                </a:solidFill>
+                <a:latin typeface="Arial"/>
+              </a:rPr>
+              <a:t>  ·  Easy wins every time</a:t>
+            </a:r>
+          </a:p>
+        </p:txBody>
+      </p:sp>
+      <p:sp>
+        <p:nvSpPr>
+          <p:cNvPr id="24" name="TextBox 23"/>
+          <p:cNvSpPr txBox="1"/>
+          <p:nvPr/>
+        </p:nvSpPr>
+        <p:spPr>
+          <a:xfrm>
+            <a:off x="10774375" y="6437376"/>
+            <a:ext cx="914400" cy="365760"/>
+          </a:xfrm>
+          <a:prstGeom prst="rect">
+            <a:avLst/>
+          </a:prstGeom>
+          <a:noFill/>
+        </p:spPr>
+        <p:txBody>
+          <a:bodyPr wrap="square" anchor="t">
+            <a:spAutoFit/>
+          </a:bodyPr>
+          <a:lstStyle/>
+          <a:p>
+            <a:pPr algn="r">
+              <a:lnSpc>
+                <a:spcPct val="100000"/>
+              </a:lnSpc>
+            </a:pPr>
+            <a:r>
+              <a:rPr sz="1200" b="1" i="0">
+                <a:solidFill>
+                  <a:srgbClr val="465753"/>
+                </a:solidFill>
+                <a:latin typeface="Arial"/>
+              </a:rPr>
+              <a:t>16</a:t>
+            </a:r>
+          </a:p>
+        </p:txBody>
+      </p:sp>
+    </p:spTree>
+  </p:cSld>
+  <p:clrMapOvr>
+    <a:masterClrMapping/>
+  </p:clrMapOvr>
+</p:sld>
+</file>
+
+<file path=ppt/slides/slide17.xml><?xml version="1.0" encoding="utf-8"?>
+<p:sld xmlns:a="http://schemas.openxmlformats.org/drawingml/2006/main" xmlns:p="http://schemas.openxmlformats.org/presentationml/2006/main" xmlns:r="http://schemas.openxmlformats.org/officeDocument/2006/relationships">
+  <p:cSld>
+    <p:bg>
+      <p:bgPr>
+        <a:solidFill>
+          <a:srgbClr val="FFFFFF"/>
+        </a:solidFill>
+        <a:effectLst/>
+      </p:bgPr>
+    </p:bg>
+    <p:spTree>
+      <p:nvGrpSpPr>
+        <p:cNvPr id="1" name=""/>
+        <p:cNvGrpSpPr/>
+        <p:nvPr/>
+      </p:nvGrpSpPr>
+      <p:grpSpPr/>
+      <p:sp>
+        <p:nvSpPr>
+          <p:cNvPr id="2" name="Rectangle 1"/>
+          <p:cNvSpPr/>
+          <p:nvPr/>
+        </p:nvSpPr>
+        <p:spPr>
+          <a:xfrm>
+            <a:off x="502920" y="566928"/>
+            <a:ext cx="109728" cy="566928"/>
+          </a:xfrm>
+          <a:prstGeom prst="rect">
+            <a:avLst/>
+          </a:prstGeom>
+          <a:solidFill>
+            <a:srgbClr val="465753"/>
+          </a:solidFill>
+          <a:ln>
+            <a:noFill/>
+          </a:ln>
+          <a:effectLst/>
+        </p:spPr>
+        <p:style>
+          <a:lnRef idx="1">
+            <a:schemeClr val="accent1"/>
+          </a:lnRef>
+          <a:fillRef idx="3">
+            <a:schemeClr val="accent1"/>
+          </a:fillRef>
+          <a:effectRef idx="2">
+            <a:schemeClr val="accent1"/>
+          </a:effectRef>
+          <a:fontRef idx="minor">
+            <a:schemeClr val="lt1"/>
+          </a:fontRef>
+        </p:style>
+        <p:txBody>
+          <a:bodyPr rtlCol="0" anchor="ctr"/>
+          <a:lstStyle/>
+          <a:p>
+            <a:pPr algn="ctr"/>
+          </a:p>
+        </p:txBody>
+      </p:sp>
+      <p:sp>
+        <p:nvSpPr>
+          <p:cNvPr id="3" name="TextBox 2"/>
+          <p:cNvSpPr txBox="1"/>
+          <p:nvPr/>
+        </p:nvSpPr>
+        <p:spPr>
+          <a:xfrm>
+            <a:off x="731520" y="457200"/>
+            <a:ext cx="10789920" cy="320040"/>
+          </a:xfrm>
+          <a:prstGeom prst="rect">
+            <a:avLst/>
+          </a:prstGeom>
+          <a:noFill/>
+        </p:spPr>
+        <p:txBody>
+          <a:bodyPr wrap="square" anchor="t">
+            <a:spAutoFit/>
+          </a:bodyPr>
+          <a:lstStyle/>
+          <a:p>
+            <a:pPr algn="l">
+              <a:lnSpc>
+                <a:spcPct val="100000"/>
+              </a:lnSpc>
+            </a:pPr>
+            <a:r>
+              <a:rPr sz="1250" b="1" i="0">
+                <a:solidFill>
+                  <a:srgbClr val="C1B49B"/>
+                </a:solidFill>
+                <a:latin typeface="Arial"/>
+              </a:rPr>
+              <a:t>ROADMAP · REMAINING MILESTONES</a:t>
+            </a:r>
+          </a:p>
+        </p:txBody>
+      </p:sp>
+      <p:sp>
+        <p:nvSpPr>
+          <p:cNvPr id="4" name="TextBox 3"/>
+          <p:cNvSpPr txBox="1"/>
+          <p:nvPr/>
+        </p:nvSpPr>
+        <p:spPr>
+          <a:xfrm>
+            <a:off x="731520" y="749808"/>
+            <a:ext cx="10881360" cy="822960"/>
+          </a:xfrm>
+          <a:prstGeom prst="rect">
+            <a:avLst/>
+          </a:prstGeom>
+          <a:noFill/>
+        </p:spPr>
+        <p:txBody>
+          <a:bodyPr wrap="square" anchor="t">
+            <a:spAutoFit/>
+          </a:bodyPr>
+          <a:lstStyle/>
+          <a:p>
+            <a:pPr algn="l">
+              <a:lnSpc>
+                <a:spcPct val="100000"/>
+              </a:lnSpc>
+            </a:pPr>
+            <a:r>
+              <a:rPr sz="3000" b="1" i="0">
+                <a:solidFill>
+                  <a:srgbClr val="28323B"/>
+                </a:solidFill>
+                <a:latin typeface="Arial"/>
+              </a:rPr>
+              <a:t>The road ahead</a:t>
+            </a:r>
+          </a:p>
+        </p:txBody>
+      </p:sp>
+      <p:sp>
+        <p:nvSpPr>
+          <p:cNvPr id="5" name="Rectangle 4"/>
+          <p:cNvSpPr/>
+          <p:nvPr/>
+        </p:nvSpPr>
+        <p:spPr>
+          <a:xfrm>
+            <a:off x="1481328" y="1920240"/>
+            <a:ext cx="36576" cy="3977639"/>
+          </a:xfrm>
+          <a:prstGeom prst="rect">
+            <a:avLst/>
+          </a:prstGeom>
+          <a:solidFill>
+            <a:srgbClr val="C1B49B"/>
+          </a:solidFill>
+          <a:ln>
+            <a:noFill/>
+          </a:ln>
+          <a:effectLst/>
+        </p:spPr>
+        <p:style>
+          <a:lnRef idx="1">
+            <a:schemeClr val="accent1"/>
+          </a:lnRef>
+          <a:fillRef idx="3">
+            <a:schemeClr val="accent1"/>
+          </a:fillRef>
+          <a:effectRef idx="2">
+            <a:schemeClr val="accent1"/>
+          </a:effectRef>
+          <a:fontRef idx="minor">
+            <a:schemeClr val="lt1"/>
+          </a:fontRef>
+        </p:style>
+        <p:txBody>
+          <a:bodyPr rtlCol="0" anchor="ctr"/>
+          <a:lstStyle/>
+          <a:p>
+            <a:pPr algn="ctr"/>
+          </a:p>
+        </p:txBody>
+      </p:sp>
+      <p:sp>
+        <p:nvSpPr>
+          <p:cNvPr id="6" name="Rectangle 5"/>
+          <p:cNvSpPr/>
+          <p:nvPr/>
+        </p:nvSpPr>
+        <p:spPr>
+          <a:xfrm>
+            <a:off x="914400" y="1828800"/>
+            <a:ext cx="1143000" cy="457200"/>
+          </a:xfrm>
+          <a:prstGeom prst="rect">
+            <a:avLst/>
+          </a:prstGeom>
+          <a:solidFill>
+            <a:srgbClr val="465753"/>
+          </a:solidFill>
+          <a:ln>
+            <a:noFill/>
+          </a:ln>
+          <a:effectLst/>
+        </p:spPr>
+        <p:style>
+          <a:lnRef idx="1">
+            <a:schemeClr val="accent1"/>
+          </a:lnRef>
+          <a:fillRef idx="3">
+            <a:schemeClr val="accent1"/>
+          </a:fillRef>
+          <a:effectRef idx="2">
+            <a:schemeClr val="accent1"/>
+          </a:effectRef>
+          <a:fontRef idx="minor">
+            <a:schemeClr val="lt1"/>
+          </a:fontRef>
+        </p:style>
+        <p:txBody>
+          <a:bodyPr rtlCol="0" anchor="ctr"/>
+          <a:lstStyle/>
+          <a:p>
+            <a:pPr algn="ctr"/>
+          </a:p>
+        </p:txBody>
+      </p:sp>
+      <p:sp>
+        <p:nvSpPr>
+          <p:cNvPr id="7" name="TextBox 6"/>
+          <p:cNvSpPr txBox="1"/>
+          <p:nvPr/>
+        </p:nvSpPr>
+        <p:spPr>
+          <a:xfrm>
+            <a:off x="914400" y="1828800"/>
+            <a:ext cx="1143000" cy="457200"/>
+          </a:xfrm>
+          <a:prstGeom prst="rect">
+            <a:avLst/>
+          </a:prstGeom>
+          <a:noFill/>
+        </p:spPr>
+        <p:txBody>
+          <a:bodyPr wrap="square" anchor="ctr">
+            <a:spAutoFit/>
+          </a:bodyPr>
+          <a:lstStyle/>
+          <a:p>
+            <a:pPr algn="ctr">
+              <a:lnSpc>
+                <a:spcPct val="100000"/>
+              </a:lnSpc>
+            </a:pPr>
+            <a:r>
+              <a:rPr sz="1800" b="1" i="0">
+                <a:solidFill>
+                  <a:srgbClr val="FFFFFF"/>
+                </a:solidFill>
+                <a:latin typeface="Arial"/>
+              </a:rPr>
+              <a:t>v0.1</a:t>
+            </a:r>
+          </a:p>
+        </p:txBody>
+      </p:sp>
+      <p:sp>
+        <p:nvSpPr>
+          <p:cNvPr id="8" name="TextBox 7"/>
+          <p:cNvSpPr txBox="1"/>
+          <p:nvPr/>
+        </p:nvSpPr>
+        <p:spPr>
+          <a:xfrm>
+            <a:off x="2377440" y="1792224"/>
+            <a:ext cx="9509760" cy="365760"/>
+          </a:xfrm>
+          <a:prstGeom prst="rect">
+            <a:avLst/>
+          </a:prstGeom>
+          <a:noFill/>
+        </p:spPr>
+        <p:txBody>
+          <a:bodyPr wrap="square" anchor="t">
+            <a:spAutoFit/>
+          </a:bodyPr>
+          <a:lstStyle/>
+          <a:p>
+            <a:pPr algn="l">
+              <a:lnSpc>
+                <a:spcPct val="100000"/>
+              </a:lnSpc>
+            </a:pPr>
+            <a:r>
+              <a:rPr sz="1800" b="1" i="0">
+                <a:solidFill>
+                  <a:srgbClr val="28323B"/>
+                </a:solidFill>
+                <a:latin typeface="Arial"/>
+              </a:rPr>
+              <a:t>Core engine &amp; MVP</a:t>
+            </a:r>
+            <a:r>
+              <a:rPr sz="1300" b="1" i="1">
+                <a:solidFill>
+                  <a:srgbClr val="B85C3C"/>
+                </a:solidFill>
+                <a:latin typeface="Arial"/>
+              </a:rPr>
+              <a:t>   finishing now</a:t>
+            </a:r>
+          </a:p>
+        </p:txBody>
+      </p:sp>
+      <p:sp>
+        <p:nvSpPr>
+          <p:cNvPr id="9" name="TextBox 8"/>
+          <p:cNvSpPr txBox="1"/>
+          <p:nvPr/>
+        </p:nvSpPr>
+        <p:spPr>
+          <a:xfrm>
+            <a:off x="2377440" y="2194560"/>
+            <a:ext cx="9509760" cy="457200"/>
+          </a:xfrm>
+          <a:prstGeom prst="rect">
+            <a:avLst/>
+          </a:prstGeom>
+          <a:noFill/>
+        </p:spPr>
+        <p:txBody>
+          <a:bodyPr wrap="square" anchor="t">
+            <a:spAutoFit/>
+          </a:bodyPr>
+          <a:lstStyle/>
+          <a:p>
+            <a:pPr algn="l">
+              <a:lnSpc>
+                <a:spcPct val="100000"/>
+              </a:lnSpc>
+            </a:pPr>
+            <a:r>
+              <a:rPr sz="1350" b="0" i="0">
+                <a:solidFill>
+                  <a:srgbClr val="6B7B6F"/>
+                </a:solidFill>
+                <a:latin typeface="Arial"/>
+              </a:rPr>
+              <a:t>Grammar · PyQGIS backend · ~40 verbs · assess · run / call</a:t>
+            </a:r>
+          </a:p>
+        </p:txBody>
+      </p:sp>
+      <p:sp>
+        <p:nvSpPr>
+          <p:cNvPr id="10" name="Rectangle 9"/>
+          <p:cNvSpPr/>
+          <p:nvPr/>
+        </p:nvSpPr>
+        <p:spPr>
+          <a:xfrm>
+            <a:off x="914400" y="2761488"/>
+            <a:ext cx="1143000" cy="457200"/>
+          </a:xfrm>
+          <a:prstGeom prst="rect">
+            <a:avLst/>
+          </a:prstGeom>
+          <a:solidFill>
+            <a:srgbClr val="465753"/>
+          </a:solidFill>
+          <a:ln>
+            <a:noFill/>
+          </a:ln>
+          <a:effectLst/>
+        </p:spPr>
+        <p:style>
+          <a:lnRef idx="1">
+            <a:schemeClr val="accent1"/>
+          </a:lnRef>
+          <a:fillRef idx="3">
+            <a:schemeClr val="accent1"/>
+          </a:fillRef>
+          <a:effectRef idx="2">
+            <a:schemeClr val="accent1"/>
+          </a:effectRef>
+          <a:fontRef idx="minor">
+            <a:schemeClr val="lt1"/>
+          </a:fontRef>
+        </p:style>
+        <p:txBody>
+          <a:bodyPr rtlCol="0" anchor="ctr"/>
+          <a:lstStyle/>
+          <a:p>
+            <a:pPr algn="ctr"/>
+          </a:p>
+        </p:txBody>
+      </p:sp>
+      <p:sp>
+        <p:nvSpPr>
+          <p:cNvPr id="11" name="TextBox 10"/>
+          <p:cNvSpPr txBox="1"/>
+          <p:nvPr/>
+        </p:nvSpPr>
+        <p:spPr>
+          <a:xfrm>
+            <a:off x="914400" y="2761488"/>
+            <a:ext cx="1143000" cy="457200"/>
+          </a:xfrm>
+          <a:prstGeom prst="rect">
+            <a:avLst/>
+          </a:prstGeom>
+          <a:noFill/>
+        </p:spPr>
+        <p:txBody>
+          <a:bodyPr wrap="square" anchor="ctr">
+            <a:spAutoFit/>
+          </a:bodyPr>
+          <a:lstStyle/>
+          <a:p>
+            <a:pPr algn="ctr">
+              <a:lnSpc>
+                <a:spcPct val="100000"/>
+              </a:lnSpc>
+            </a:pPr>
+            <a:r>
+              <a:rPr sz="1800" b="1" i="0">
+                <a:solidFill>
+                  <a:srgbClr val="FFFFFF"/>
+                </a:solidFill>
+                <a:latin typeface="Arial"/>
+              </a:rPr>
+              <a:t>v0.2</a:t>
+            </a:r>
+          </a:p>
+        </p:txBody>
+      </p:sp>
+      <p:sp>
+        <p:nvSpPr>
+          <p:cNvPr id="12" name="TextBox 11"/>
+          <p:cNvSpPr txBox="1"/>
+          <p:nvPr/>
+        </p:nvSpPr>
+        <p:spPr>
+          <a:xfrm>
+            <a:off x="2377440" y="2724912"/>
+            <a:ext cx="9509760" cy="365760"/>
+          </a:xfrm>
+          <a:prstGeom prst="rect">
+            <a:avLst/>
+          </a:prstGeom>
+          <a:noFill/>
+        </p:spPr>
+        <p:txBody>
+          <a:bodyPr wrap="square" anchor="t">
+            <a:spAutoFit/>
+          </a:bodyPr>
+          <a:lstStyle/>
+          <a:p>
+            <a:pPr algn="l">
+              <a:lnSpc>
+                <a:spcPct val="100000"/>
+              </a:lnSpc>
+            </a:pPr>
+            <a:r>
+              <a:rPr sz="1800" b="1" i="0">
+                <a:solidFill>
+                  <a:srgbClr val="28323B"/>
+                </a:solidFill>
+                <a:latin typeface="Arial"/>
+              </a:rPr>
+              <a:t>Breadth &amp; provenance</a:t>
+            </a:r>
+          </a:p>
+        </p:txBody>
+      </p:sp>
+      <p:sp>
+        <p:nvSpPr>
+          <p:cNvPr id="13" name="TextBox 12"/>
+          <p:cNvSpPr txBox="1"/>
+          <p:nvPr/>
+        </p:nvSpPr>
+        <p:spPr>
+          <a:xfrm>
+            <a:off x="2377440" y="3127248"/>
+            <a:ext cx="9509760" cy="457200"/>
+          </a:xfrm>
+          <a:prstGeom prst="rect">
+            <a:avLst/>
+          </a:prstGeom>
+          <a:noFill/>
+        </p:spPr>
+        <p:txBody>
+          <a:bodyPr wrap="square" anchor="t">
+            <a:spAutoFit/>
+          </a:bodyPr>
+          <a:lstStyle/>
+          <a:p>
+            <a:pPr algn="l">
+              <a:lnSpc>
+                <a:spcPct val="100000"/>
+              </a:lnSpc>
+            </a:pPr>
+            <a:r>
+              <a:rPr sz="1350" b="0" i="0">
+                <a:solidFill>
+                  <a:srgbClr val="6B7B6F"/>
+                </a:solidFill>
+                <a:latin typeface="Arial"/>
+              </a:rPr>
+              <a:t>Tier-2 + raster verbs · auto-lineage → metadata · richer filter · qgis_process backend · docs</a:t>
+            </a:r>
+          </a:p>
+        </p:txBody>
+      </p:sp>
+      <p:sp>
+        <p:nvSpPr>
+          <p:cNvPr id="14" name="Rectangle 13"/>
+          <p:cNvSpPr/>
+          <p:nvPr/>
+        </p:nvSpPr>
+        <p:spPr>
+          <a:xfrm>
+            <a:off x="914400" y="3694176"/>
+            <a:ext cx="1143000" cy="457200"/>
+          </a:xfrm>
+          <a:prstGeom prst="rect">
+            <a:avLst/>
+          </a:prstGeom>
+          <a:solidFill>
+            <a:srgbClr val="465753"/>
+          </a:solidFill>
+          <a:ln>
+            <a:noFill/>
+          </a:ln>
+          <a:effectLst/>
+        </p:spPr>
+        <p:style>
+          <a:lnRef idx="1">
+            <a:schemeClr val="accent1"/>
+          </a:lnRef>
+          <a:fillRef idx="3">
+            <a:schemeClr val="accent1"/>
+          </a:fillRef>
+          <a:effectRef idx="2">
+            <a:schemeClr val="accent1"/>
+          </a:effectRef>
+          <a:fontRef idx="minor">
+            <a:schemeClr val="lt1"/>
+          </a:fontRef>
+        </p:style>
+        <p:txBody>
+          <a:bodyPr rtlCol="0" anchor="ctr"/>
+          <a:lstStyle/>
+          <a:p>
+            <a:pPr algn="ctr"/>
+          </a:p>
+        </p:txBody>
+      </p:sp>
+      <p:sp>
+        <p:nvSpPr>
+          <p:cNvPr id="15" name="TextBox 14"/>
+          <p:cNvSpPr txBox="1"/>
+          <p:nvPr/>
+        </p:nvSpPr>
+        <p:spPr>
+          <a:xfrm>
+            <a:off x="914400" y="3694176"/>
+            <a:ext cx="1143000" cy="457200"/>
+          </a:xfrm>
+          <a:prstGeom prst="rect">
+            <a:avLst/>
+          </a:prstGeom>
+          <a:noFill/>
+        </p:spPr>
+        <p:txBody>
+          <a:bodyPr wrap="square" anchor="ctr">
+            <a:spAutoFit/>
+          </a:bodyPr>
+          <a:lstStyle/>
+          <a:p>
+            <a:pPr algn="ctr">
+              <a:lnSpc>
+                <a:spcPct val="100000"/>
+              </a:lnSpc>
+            </a:pPr>
+            <a:r>
+              <a:rPr sz="1800" b="1" i="0">
+                <a:solidFill>
+                  <a:srgbClr val="FFFFFF"/>
+                </a:solidFill>
+                <a:latin typeface="Arial"/>
+              </a:rPr>
+              <a:t>v1.0</a:t>
+            </a:r>
+          </a:p>
+        </p:txBody>
+      </p:sp>
+      <p:sp>
+        <p:nvSpPr>
+          <p:cNvPr id="16" name="TextBox 15"/>
+          <p:cNvSpPr txBox="1"/>
+          <p:nvPr/>
+        </p:nvSpPr>
+        <p:spPr>
+          <a:xfrm>
+            <a:off x="2377440" y="3657600"/>
+            <a:ext cx="9509760" cy="365760"/>
+          </a:xfrm>
+          <a:prstGeom prst="rect">
+            <a:avLst/>
+          </a:prstGeom>
+          <a:noFill/>
+        </p:spPr>
+        <p:txBody>
+          <a:bodyPr wrap="square" anchor="t">
+            <a:spAutoFit/>
+          </a:bodyPr>
+          <a:lstStyle/>
+          <a:p>
+            <a:pPr algn="l">
+              <a:lnSpc>
+                <a:spcPct val="100000"/>
+              </a:lnSpc>
+            </a:pPr>
+            <a:r>
+              <a:rPr sz="1800" b="1" i="0">
+                <a:solidFill>
+                  <a:srgbClr val="28323B"/>
+                </a:solidFill>
+                <a:latin typeface="Arial"/>
+              </a:rPr>
+              <a:t>Stable release</a:t>
+            </a:r>
+          </a:p>
+        </p:txBody>
+      </p:sp>
+      <p:sp>
+        <p:nvSpPr>
+          <p:cNvPr id="17" name="TextBox 16"/>
+          <p:cNvSpPr txBox="1"/>
+          <p:nvPr/>
+        </p:nvSpPr>
+        <p:spPr>
+          <a:xfrm>
+            <a:off x="2377440" y="4059936"/>
+            <a:ext cx="9509760" cy="457200"/>
+          </a:xfrm>
+          <a:prstGeom prst="rect">
+            <a:avLst/>
+          </a:prstGeom>
+          <a:noFill/>
+        </p:spPr>
+        <p:txBody>
+          <a:bodyPr wrap="square" anchor="t">
+            <a:spAutoFit/>
+          </a:bodyPr>
+          <a:lstStyle/>
+          <a:p>
+            <a:pPr algn="l">
+              <a:lnSpc>
+                <a:spcPct val="100000"/>
+              </a:lnSpc>
+            </a:pPr>
+            <a:r>
+              <a:rPr sz="1350" b="0" i="0">
+                <a:solidFill>
+                  <a:srgbClr val="6B7B6F"/>
+                </a:solidFill>
+                <a:latin typeface="Arial"/>
+              </a:rPr>
+              <a:t>Grammar freeze (SemVer) · PyPI publish · worked Marimo–QGIS integration</a:t>
+            </a:r>
+          </a:p>
+        </p:txBody>
+      </p:sp>
+      <p:sp>
+        <p:nvSpPr>
+          <p:cNvPr id="18" name="Rectangle 17"/>
+          <p:cNvSpPr/>
+          <p:nvPr/>
+        </p:nvSpPr>
+        <p:spPr>
+          <a:xfrm>
+            <a:off x="914400" y="4626864"/>
+            <a:ext cx="1143000" cy="457200"/>
+          </a:xfrm>
+          <a:prstGeom prst="rect">
+            <a:avLst/>
+          </a:prstGeom>
+          <a:solidFill>
+            <a:srgbClr val="465753"/>
+          </a:solidFill>
+          <a:ln>
+            <a:noFill/>
+          </a:ln>
+          <a:effectLst/>
+        </p:spPr>
+        <p:style>
+          <a:lnRef idx="1">
+            <a:schemeClr val="accent1"/>
+          </a:lnRef>
+          <a:fillRef idx="3">
+            <a:schemeClr val="accent1"/>
+          </a:fillRef>
+          <a:effectRef idx="2">
+            <a:schemeClr val="accent1"/>
+          </a:effectRef>
+          <a:fontRef idx="minor">
+            <a:schemeClr val="lt1"/>
+          </a:fontRef>
+        </p:style>
+        <p:txBody>
+          <a:bodyPr rtlCol="0" anchor="ctr"/>
+          <a:lstStyle/>
+          <a:p>
+            <a:pPr algn="ctr"/>
+          </a:p>
+        </p:txBody>
+      </p:sp>
+      <p:sp>
+        <p:nvSpPr>
+          <p:cNvPr id="19" name="TextBox 18"/>
+          <p:cNvSpPr txBox="1"/>
+          <p:nvPr/>
+        </p:nvSpPr>
+        <p:spPr>
+          <a:xfrm>
+            <a:off x="914400" y="4626864"/>
+            <a:ext cx="1143000" cy="457200"/>
+          </a:xfrm>
+          <a:prstGeom prst="rect">
+            <a:avLst/>
+          </a:prstGeom>
+          <a:noFill/>
+        </p:spPr>
+        <p:txBody>
+          <a:bodyPr wrap="square" anchor="ctr">
+            <a:spAutoFit/>
+          </a:bodyPr>
+          <a:lstStyle/>
+          <a:p>
+            <a:pPr algn="ctr">
+              <a:lnSpc>
+                <a:spcPct val="100000"/>
+              </a:lnSpc>
+            </a:pPr>
+            <a:r>
+              <a:rPr sz="1800" b="1" i="0">
+                <a:solidFill>
+                  <a:srgbClr val="FFFFFF"/>
+                </a:solidFill>
+                <a:latin typeface="Arial"/>
+              </a:rPr>
+              <a:t>v2.0</a:t>
+            </a:r>
+          </a:p>
+        </p:txBody>
+      </p:sp>
+      <p:sp>
+        <p:nvSpPr>
+          <p:cNvPr id="20" name="TextBox 19"/>
+          <p:cNvSpPr txBox="1"/>
+          <p:nvPr/>
+        </p:nvSpPr>
+        <p:spPr>
+          <a:xfrm>
+            <a:off x="2377440" y="4590288"/>
+            <a:ext cx="9509760" cy="365760"/>
+          </a:xfrm>
+          <a:prstGeom prst="rect">
+            <a:avLst/>
+          </a:prstGeom>
+          <a:noFill/>
+        </p:spPr>
+        <p:txBody>
+          <a:bodyPr wrap="square" anchor="t">
+            <a:spAutoFit/>
+          </a:bodyPr>
+          <a:lstStyle/>
+          <a:p>
+            <a:pPr algn="l">
+              <a:lnSpc>
+                <a:spcPct val="100000"/>
+              </a:lnSpc>
+            </a:pPr>
+            <a:r>
+              <a:rPr sz="1800" b="1" i="0">
+                <a:solidFill>
+                  <a:srgbClr val="28323B"/>
+                </a:solidFill>
+                <a:latin typeface="Arial"/>
+              </a:rPr>
+              <a:t>Power features</a:t>
+            </a:r>
+          </a:p>
+        </p:txBody>
+      </p:sp>
+      <p:sp>
+        <p:nvSpPr>
+          <p:cNvPr id="21" name="TextBox 20"/>
+          <p:cNvSpPr txBox="1"/>
+          <p:nvPr/>
+        </p:nvSpPr>
+        <p:spPr>
+          <a:xfrm>
+            <a:off x="2377440" y="4992624"/>
+            <a:ext cx="9509760" cy="457200"/>
+          </a:xfrm>
+          <a:prstGeom prst="rect">
+            <a:avLst/>
+          </a:prstGeom>
+          <a:noFill/>
+        </p:spPr>
+        <p:txBody>
+          <a:bodyPr wrap="square" anchor="t">
+            <a:spAutoFit/>
+          </a:bodyPr>
+          <a:lstStyle/>
+          <a:p>
+            <a:pPr algn="l">
+              <a:lnSpc>
+                <a:spcPct val="100000"/>
+              </a:lnSpc>
+            </a:pPr>
+            <a:r>
+              <a:rPr sz="1350" b="0" i="0">
+                <a:solidFill>
+                  <a:srgbClr val="6B7B6F"/>
+                </a:solidFill>
+                <a:latin typeface="Arial"/>
+              </a:rPr>
+              <a:t>Named intermediates &amp; variables · SQL writes · quality rules &amp; constraints</a:t>
+            </a:r>
+          </a:p>
+        </p:txBody>
+      </p:sp>
+      <p:sp>
+        <p:nvSpPr>
+          <p:cNvPr id="22" name="Rectangle 21"/>
+          <p:cNvSpPr/>
+          <p:nvPr/>
+        </p:nvSpPr>
+        <p:spPr>
+          <a:xfrm>
+            <a:off x="914400" y="5559552"/>
+            <a:ext cx="1143000" cy="457200"/>
+          </a:xfrm>
+          <a:prstGeom prst="rect">
+            <a:avLst/>
+          </a:prstGeom>
+          <a:solidFill>
+            <a:srgbClr val="465753"/>
+          </a:solidFill>
+          <a:ln>
+            <a:noFill/>
+          </a:ln>
+          <a:effectLst/>
+        </p:spPr>
+        <p:style>
+          <a:lnRef idx="1">
+            <a:schemeClr val="accent1"/>
+          </a:lnRef>
+          <a:fillRef idx="3">
+            <a:schemeClr val="accent1"/>
+          </a:fillRef>
+          <a:effectRef idx="2">
+            <a:schemeClr val="accent1"/>
+          </a:effectRef>
+          <a:fontRef idx="minor">
+            <a:schemeClr val="lt1"/>
+          </a:fontRef>
+        </p:style>
+        <p:txBody>
+          <a:bodyPr rtlCol="0" anchor="ctr"/>
+          <a:lstStyle/>
+          <a:p>
+            <a:pPr algn="ctr"/>
+          </a:p>
+        </p:txBody>
+      </p:sp>
+      <p:sp>
+        <p:nvSpPr>
+          <p:cNvPr id="23" name="TextBox 22"/>
+          <p:cNvSpPr txBox="1"/>
+          <p:nvPr/>
+        </p:nvSpPr>
+        <p:spPr>
+          <a:xfrm>
+            <a:off x="914400" y="5559552"/>
+            <a:ext cx="1143000" cy="457200"/>
+          </a:xfrm>
+          <a:prstGeom prst="rect">
+            <a:avLst/>
+          </a:prstGeom>
+          <a:noFill/>
+        </p:spPr>
+        <p:txBody>
+          <a:bodyPr wrap="square" anchor="ctr">
+            <a:spAutoFit/>
+          </a:bodyPr>
+          <a:lstStyle/>
+          <a:p>
+            <a:pPr algn="ctr">
+              <a:lnSpc>
+                <a:spcPct val="100000"/>
+              </a:lnSpc>
+            </a:pPr>
+            <a:r>
+              <a:rPr sz="1800" b="1" i="0">
+                <a:solidFill>
+                  <a:srgbClr val="FFFFFF"/>
+                </a:solidFill>
+                <a:latin typeface="Arial"/>
+              </a:rPr>
+              <a:t>v2.x</a:t>
+            </a:r>
+          </a:p>
+        </p:txBody>
+      </p:sp>
+      <p:sp>
+        <p:nvSpPr>
+          <p:cNvPr id="24" name="TextBox 23"/>
+          <p:cNvSpPr txBox="1"/>
+          <p:nvPr/>
+        </p:nvSpPr>
+        <p:spPr>
+          <a:xfrm>
+            <a:off x="2377440" y="5522976"/>
+            <a:ext cx="9509760" cy="365760"/>
+          </a:xfrm>
+          <a:prstGeom prst="rect">
+            <a:avLst/>
+          </a:prstGeom>
+          <a:noFill/>
+        </p:spPr>
+        <p:txBody>
+          <a:bodyPr wrap="square" anchor="t">
+            <a:spAutoFit/>
+          </a:bodyPr>
+          <a:lstStyle/>
+          <a:p>
+            <a:pPr algn="l">
+              <a:lnSpc>
+                <a:spcPct val="100000"/>
+              </a:lnSpc>
+            </a:pPr>
+            <a:r>
+              <a:rPr sz="1800" b="1" i="0">
+                <a:solidFill>
+                  <a:srgbClr val="28323B"/>
+                </a:solidFill>
+                <a:latin typeface="Arial"/>
+              </a:rPr>
+              <a:t>Front ends &amp; service mode</a:t>
+            </a:r>
+          </a:p>
+        </p:txBody>
+      </p:sp>
+      <p:sp>
+        <p:nvSpPr>
+          <p:cNvPr id="25" name="TextBox 24"/>
+          <p:cNvSpPr txBox="1"/>
+          <p:nvPr/>
+        </p:nvSpPr>
+        <p:spPr>
+          <a:xfrm>
+            <a:off x="2377440" y="5925312"/>
+            <a:ext cx="9509760" cy="457200"/>
+          </a:xfrm>
+          <a:prstGeom prst="rect">
+            <a:avLst/>
+          </a:prstGeom>
+          <a:noFill/>
+        </p:spPr>
+        <p:txBody>
+          <a:bodyPr wrap="square" anchor="t">
+            <a:spAutoFit/>
+          </a:bodyPr>
+          <a:lstStyle/>
+          <a:p>
+            <a:pPr algn="l">
+              <a:lnSpc>
+                <a:spcPct val="100000"/>
+              </a:lnSpc>
+            </a:pPr>
+            <a:r>
+              <a:rPr sz="1350" b="0" i="0">
+                <a:solidFill>
+                  <a:srgbClr val="6B7B6F"/>
+                </a:solidFill>
+                <a:latin typeface="Arial"/>
+              </a:rPr>
+              <a:t>QGIS plugin / Processing-Toolbox · service / daemon mode · layout &amp; symbology export</a:t>
+            </a:r>
+          </a:p>
+        </p:txBody>
+      </p:sp>
+      <p:sp>
+        <p:nvSpPr>
+          <p:cNvPr id="26" name="Rectangle 25"/>
+          <p:cNvSpPr/>
+          <p:nvPr/>
+        </p:nvSpPr>
+        <p:spPr>
+          <a:xfrm>
+            <a:off x="0" y="6565392"/>
+            <a:ext cx="12191695" cy="54864"/>
+          </a:xfrm>
+          <a:prstGeom prst="rect">
+            <a:avLst/>
+          </a:prstGeom>
+          <a:solidFill>
+            <a:srgbClr val="C1B49B"/>
+          </a:solidFill>
+          <a:ln>
+            <a:noFill/>
+          </a:ln>
+          <a:effectLst/>
+        </p:spPr>
+        <p:style>
+          <a:lnRef idx="1">
+            <a:schemeClr val="accent1"/>
+          </a:lnRef>
+          <a:fillRef idx="3">
+            <a:schemeClr val="accent1"/>
+          </a:fillRef>
+          <a:effectRef idx="2">
+            <a:schemeClr val="accent1"/>
+          </a:effectRef>
+          <a:fontRef idx="minor">
+            <a:schemeClr val="lt1"/>
+          </a:fontRef>
+        </p:style>
+        <p:txBody>
+          <a:bodyPr rtlCol="0" anchor="ctr"/>
+          <a:lstStyle/>
+          <a:p>
+            <a:pPr algn="ctr"/>
+          </a:p>
+        </p:txBody>
+      </p:sp>
+      <p:sp>
+        <p:nvSpPr>
+          <p:cNvPr id="27" name="TextBox 26"/>
+          <p:cNvSpPr txBox="1"/>
+          <p:nvPr/>
+        </p:nvSpPr>
+        <p:spPr>
+          <a:xfrm>
+            <a:off x="502920" y="6437376"/>
+            <a:ext cx="5486400" cy="365760"/>
+          </a:xfrm>
+          <a:prstGeom prst="rect">
+            <a:avLst/>
+          </a:prstGeom>
+          <a:noFill/>
+        </p:spPr>
+        <p:txBody>
+          <a:bodyPr wrap="square" anchor="t">
+            <a:spAutoFit/>
+          </a:bodyPr>
+          <a:lstStyle/>
+          <a:p>
+            <a:pPr algn="l">
+              <a:lnSpc>
+                <a:spcPct val="100000"/>
+              </a:lnSpc>
+            </a:pPr>
+            <a:r>
+              <a:rPr sz="1200" b="1" i="0">
+                <a:solidFill>
+                  <a:srgbClr val="465753"/>
+                </a:solidFill>
+                <a:latin typeface="Arial"/>
+              </a:rPr>
+              <a:t>niva</a:t>
+            </a:r>
+            <a:r>
+              <a:rPr sz="1200" b="0" i="0">
+                <a:solidFill>
+                  <a:srgbClr val="465753"/>
+                </a:solidFill>
+                <a:latin typeface="Arial"/>
+              </a:rPr>
+              <a:t>  ·  Easy wins every time</a:t>
+            </a:r>
+          </a:p>
+        </p:txBody>
+      </p:sp>
+      <p:sp>
+        <p:nvSpPr>
+          <p:cNvPr id="28" name="TextBox 27"/>
+          <p:cNvSpPr txBox="1"/>
+          <p:nvPr/>
+        </p:nvSpPr>
+        <p:spPr>
+          <a:xfrm>
+            <a:off x="10774375" y="6437376"/>
+            <a:ext cx="914400" cy="365760"/>
+          </a:xfrm>
+          <a:prstGeom prst="rect">
+            <a:avLst/>
+          </a:prstGeom>
+          <a:noFill/>
+        </p:spPr>
+        <p:txBody>
+          <a:bodyPr wrap="square" anchor="t">
+            <a:spAutoFit/>
+          </a:bodyPr>
+          <a:lstStyle/>
+          <a:p>
+            <a:pPr algn="r">
+              <a:lnSpc>
+                <a:spcPct val="100000"/>
+              </a:lnSpc>
+            </a:pPr>
+            <a:r>
+              <a:rPr sz="1200" b="1" i="0">
+                <a:solidFill>
+                  <a:srgbClr val="465753"/>
+                </a:solidFill>
+                <a:latin typeface="Arial"/>
+              </a:rPr>
+              <a:t>17</a:t>
+            </a:r>
+          </a:p>
+        </p:txBody>
+      </p:sp>
+    </p:spTree>
+  </p:cSld>
+  <p:clrMapOvr>
+    <a:masterClrMapping/>
+  </p:clrMapOvr>
+</p:sld>
+</file>
+
+<file path=ppt/slides/slide18.xml><?xml version="1.0" encoding="utf-8"?>
+<p:sld xmlns:a="http://schemas.openxmlformats.org/drawingml/2006/main" xmlns:p="http://schemas.openxmlformats.org/presentationml/2006/main" xmlns:r="http://schemas.openxmlformats.org/officeDocument/2006/relationships">
+  <p:cSld>
+    <p:bg>
+      <p:bgPr>
+        <a:solidFill>
+          <a:srgbClr val="FFFFFF"/>
+        </a:solidFill>
+        <a:effectLst/>
+      </p:bgPr>
+    </p:bg>
+    <p:spTree>
+      <p:nvGrpSpPr>
+        <p:cNvPr id="1" name=""/>
+        <p:cNvGrpSpPr/>
+        <p:nvPr/>
+      </p:nvGrpSpPr>
+      <p:grpSpPr/>
+      <p:sp>
+        <p:nvSpPr>
+          <p:cNvPr id="2" name="Rectangle 1"/>
+          <p:cNvSpPr/>
+          <p:nvPr/>
+        </p:nvSpPr>
+        <p:spPr>
+          <a:xfrm>
             <a:off x="0" y="0"/>
             <a:ext cx="12191695" cy="6858000"/>
           </a:xfrm>
@@ -7423,7 +9780,7 @@
         </p:nvSpPr>
         <p:spPr>
           <a:xfrm>
-            <a:off x="502920" y="6455664"/>
+            <a:off x="502920" y="6437376"/>
             <a:ext cx="5486400" cy="365760"/>
           </a:xfrm>
           <a:prstGeom prst="rect">
@@ -7443,7 +9800,7 @@
               </a:lnSpc>
             </a:pPr>
             <a:r>
-              <a:rPr sz="1100" b="1" i="0">
+              <a:rPr sz="1200" b="1" i="0">
                 <a:solidFill>
                   <a:srgbClr val="465753"/>
                 </a:solidFill>
@@ -7452,9 +9809,9 @@
               <a:t>niva</a:t>
             </a:r>
             <a:r>
-              <a:rPr sz="1100" b="0" i="0">
-                <a:solidFill>
-                  <a:srgbClr val="92988E"/>
+              <a:rPr sz="1200" b="0" i="0">
+                <a:solidFill>
+                  <a:srgbClr val="465753"/>
                 </a:solidFill>
                 <a:latin typeface="Arial"/>
               </a:rPr>
@@ -7471,7 +9828,7 @@
         </p:nvSpPr>
         <p:spPr>
           <a:xfrm>
-            <a:off x="10774375" y="6455664"/>
+            <a:off x="10774375" y="6437376"/>
             <a:ext cx="914400" cy="365760"/>
           </a:xfrm>
           <a:prstGeom prst="rect">
@@ -7491,9 +9848,9 @@
               </a:lnSpc>
             </a:pPr>
             <a:r>
-              <a:rPr sz="1100" b="0" i="0">
-                <a:solidFill>
-                  <a:srgbClr val="92988E"/>
+              <a:rPr sz="1200" b="1" i="0">
+                <a:solidFill>
+                  <a:srgbClr val="465753"/>
                 </a:solidFill>
                 <a:latin typeface="Arial"/>
               </a:rPr>
@@ -8166,7 +10523,7 @@
         </p:nvSpPr>
         <p:spPr>
           <a:xfrm>
-            <a:off x="502920" y="6455664"/>
+            <a:off x="502920" y="6437376"/>
             <a:ext cx="5486400" cy="365760"/>
           </a:xfrm>
           <a:prstGeom prst="rect">
@@ -8186,7 +10543,7 @@
               </a:lnSpc>
             </a:pPr>
             <a:r>
-              <a:rPr sz="1100" b="1" i="0">
+              <a:rPr sz="1200" b="1" i="0">
                 <a:solidFill>
                   <a:srgbClr val="465753"/>
                 </a:solidFill>
@@ -8195,9 +10552,9 @@
               <a:t>niva</a:t>
             </a:r>
             <a:r>
-              <a:rPr sz="1100" b="0" i="0">
-                <a:solidFill>
-                  <a:srgbClr val="92988E"/>
+              <a:rPr sz="1200" b="0" i="0">
+                <a:solidFill>
+                  <a:srgbClr val="465753"/>
                 </a:solidFill>
                 <a:latin typeface="Arial"/>
               </a:rPr>
@@ -8214,7 +10571,7 @@
         </p:nvSpPr>
         <p:spPr>
           <a:xfrm>
-            <a:off x="10774375" y="6455664"/>
+            <a:off x="10774375" y="6437376"/>
             <a:ext cx="914400" cy="365760"/>
           </a:xfrm>
           <a:prstGeom prst="rect">
@@ -8234,9 +10591,9 @@
               </a:lnSpc>
             </a:pPr>
             <a:r>
-              <a:rPr sz="1100" b="0" i="0">
-                <a:solidFill>
-                  <a:srgbClr val="92988E"/>
+              <a:rPr sz="1200" b="1" i="0">
+                <a:solidFill>
+                  <a:srgbClr val="465753"/>
                 </a:solidFill>
                 <a:latin typeface="Arial"/>
               </a:rPr>
@@ -8469,7 +10826,7 @@
         </p:nvSpPr>
         <p:spPr>
           <a:xfrm>
-            <a:off x="502920" y="6455664"/>
+            <a:off x="502920" y="6437376"/>
             <a:ext cx="5486400" cy="365760"/>
           </a:xfrm>
           <a:prstGeom prst="rect">
@@ -8489,7 +10846,7 @@
               </a:lnSpc>
             </a:pPr>
             <a:r>
-              <a:rPr sz="1100" b="1" i="0">
+              <a:rPr sz="1200" b="1" i="0">
                 <a:solidFill>
                   <a:srgbClr val="465753"/>
                 </a:solidFill>
@@ -8498,9 +10855,9 @@
               <a:t>niva</a:t>
             </a:r>
             <a:r>
-              <a:rPr sz="1100" b="0" i="0">
-                <a:solidFill>
-                  <a:srgbClr val="92988E"/>
+              <a:rPr sz="1200" b="0" i="0">
+                <a:solidFill>
+                  <a:srgbClr val="465753"/>
                 </a:solidFill>
                 <a:latin typeface="Arial"/>
               </a:rPr>
@@ -8517,7 +10874,7 @@
         </p:nvSpPr>
         <p:spPr>
           <a:xfrm>
-            <a:off x="10774375" y="6455664"/>
+            <a:off x="10774375" y="6437376"/>
             <a:ext cx="914400" cy="365760"/>
           </a:xfrm>
           <a:prstGeom prst="rect">
@@ -8537,9 +10894,9 @@
               </a:lnSpc>
             </a:pPr>
             <a:r>
-              <a:rPr sz="1100" b="0" i="0">
-                <a:solidFill>
-                  <a:srgbClr val="92988E"/>
+              <a:rPr sz="1200" b="1" i="0">
+                <a:solidFill>
+                  <a:srgbClr val="465753"/>
                 </a:solidFill>
                 <a:latin typeface="Arial"/>
               </a:rPr>
@@ -9074,7 +11431,7 @@
         </p:nvSpPr>
         <p:spPr>
           <a:xfrm>
-            <a:off x="502920" y="6455664"/>
+            <a:off x="502920" y="6437376"/>
             <a:ext cx="5486400" cy="365760"/>
           </a:xfrm>
           <a:prstGeom prst="rect">
@@ -9094,7 +11451,7 @@
               </a:lnSpc>
             </a:pPr>
             <a:r>
-              <a:rPr sz="1100" b="1" i="0">
+              <a:rPr sz="1200" b="1" i="0">
                 <a:solidFill>
                   <a:srgbClr val="465753"/>
                 </a:solidFill>
@@ -9103,9 +11460,9 @@
               <a:t>niva</a:t>
             </a:r>
             <a:r>
-              <a:rPr sz="1100" b="0" i="0">
-                <a:solidFill>
-                  <a:srgbClr val="92988E"/>
+              <a:rPr sz="1200" b="0" i="0">
+                <a:solidFill>
+                  <a:srgbClr val="465753"/>
                 </a:solidFill>
                 <a:latin typeface="Arial"/>
               </a:rPr>
@@ -9122,7 +11479,7 @@
         </p:nvSpPr>
         <p:spPr>
           <a:xfrm>
-            <a:off x="10774375" y="6455664"/>
+            <a:off x="10774375" y="6437376"/>
             <a:ext cx="914400" cy="365760"/>
           </a:xfrm>
           <a:prstGeom prst="rect">
@@ -9142,9 +11499,9 @@
               </a:lnSpc>
             </a:pPr>
             <a:r>
-              <a:rPr sz="1100" b="0" i="0">
-                <a:solidFill>
-                  <a:srgbClr val="92988E"/>
+              <a:rPr sz="1200" b="1" i="0">
+                <a:solidFill>
+                  <a:srgbClr val="465753"/>
                 </a:solidFill>
                 <a:latin typeface="Arial"/>
               </a:rPr>
@@ -9852,7 +12209,7 @@
         </p:nvSpPr>
         <p:spPr>
           <a:xfrm>
-            <a:off x="502920" y="6455664"/>
+            <a:off x="502920" y="6437376"/>
             <a:ext cx="5486400" cy="365760"/>
           </a:xfrm>
           <a:prstGeom prst="rect">
@@ -9872,7 +12229,7 @@
               </a:lnSpc>
             </a:pPr>
             <a:r>
-              <a:rPr sz="1100" b="1" i="0">
+              <a:rPr sz="1200" b="1" i="0">
                 <a:solidFill>
                   <a:srgbClr val="465753"/>
                 </a:solidFill>
@@ -9881,9 +12238,9 @@
               <a:t>niva</a:t>
             </a:r>
             <a:r>
-              <a:rPr sz="1100" b="0" i="0">
-                <a:solidFill>
-                  <a:srgbClr val="92988E"/>
+              <a:rPr sz="1200" b="0" i="0">
+                <a:solidFill>
+                  <a:srgbClr val="465753"/>
                 </a:solidFill>
                 <a:latin typeface="Arial"/>
               </a:rPr>
@@ -9900,7 +12257,7 @@
         </p:nvSpPr>
         <p:spPr>
           <a:xfrm>
-            <a:off x="10774375" y="6455664"/>
+            <a:off x="10774375" y="6437376"/>
             <a:ext cx="914400" cy="365760"/>
           </a:xfrm>
           <a:prstGeom prst="rect">
@@ -9920,9 +12277,9 @@
               </a:lnSpc>
             </a:pPr>
             <a:r>
-              <a:rPr sz="1100" b="0" i="0">
-                <a:solidFill>
-                  <a:srgbClr val="92988E"/>
+              <a:rPr sz="1200" b="1" i="0">
+                <a:solidFill>
+                  <a:srgbClr val="465753"/>
                 </a:solidFill>
                 <a:latin typeface="Arial"/>
               </a:rPr>
@@ -10586,7 +12943,7 @@
         </p:nvSpPr>
         <p:spPr>
           <a:xfrm>
-            <a:off x="502920" y="6455664"/>
+            <a:off x="502920" y="6437376"/>
             <a:ext cx="5486400" cy="365760"/>
           </a:xfrm>
           <a:prstGeom prst="rect">
@@ -10606,7 +12963,7 @@
               </a:lnSpc>
             </a:pPr>
             <a:r>
-              <a:rPr sz="1100" b="1" i="0">
+              <a:rPr sz="1200" b="1" i="0">
                 <a:solidFill>
                   <a:srgbClr val="465753"/>
                 </a:solidFill>
@@ -10615,9 +12972,9 @@
               <a:t>niva</a:t>
             </a:r>
             <a:r>
-              <a:rPr sz="1100" b="0" i="0">
-                <a:solidFill>
-                  <a:srgbClr val="92988E"/>
+              <a:rPr sz="1200" b="0" i="0">
+                <a:solidFill>
+                  <a:srgbClr val="465753"/>
                 </a:solidFill>
                 <a:latin typeface="Arial"/>
               </a:rPr>
@@ -10634,7 +12991,7 @@
         </p:nvSpPr>
         <p:spPr>
           <a:xfrm>
-            <a:off x="10774375" y="6455664"/>
+            <a:off x="10774375" y="6437376"/>
             <a:ext cx="914400" cy="365760"/>
           </a:xfrm>
           <a:prstGeom prst="rect">
@@ -10654,9 +13011,9 @@
               </a:lnSpc>
             </a:pPr>
             <a:r>
-              <a:rPr sz="1100" b="0" i="0">
-                <a:solidFill>
-                  <a:srgbClr val="92988E"/>
+              <a:rPr sz="1200" b="1" i="0">
+                <a:solidFill>
+                  <a:srgbClr val="465753"/>
                 </a:solidFill>
                 <a:latin typeface="Arial"/>
               </a:rPr>
@@ -10889,7 +13246,7 @@
         </p:nvSpPr>
         <p:spPr>
           <a:xfrm>
-            <a:off x="502920" y="6455664"/>
+            <a:off x="502920" y="6437376"/>
             <a:ext cx="5486400" cy="365760"/>
           </a:xfrm>
           <a:prstGeom prst="rect">
@@ -10909,7 +13266,7 @@
               </a:lnSpc>
             </a:pPr>
             <a:r>
-              <a:rPr sz="1100" b="1" i="0">
+              <a:rPr sz="1200" b="1" i="0">
                 <a:solidFill>
                   <a:srgbClr val="465753"/>
                 </a:solidFill>
@@ -10918,9 +13275,9 @@
               <a:t>niva</a:t>
             </a:r>
             <a:r>
-              <a:rPr sz="1100" b="0" i="0">
-                <a:solidFill>
-                  <a:srgbClr val="92988E"/>
+              <a:rPr sz="1200" b="0" i="0">
+                <a:solidFill>
+                  <a:srgbClr val="465753"/>
                 </a:solidFill>
                 <a:latin typeface="Arial"/>
               </a:rPr>
@@ -10937,7 +13294,7 @@
         </p:nvSpPr>
         <p:spPr>
           <a:xfrm>
-            <a:off x="10774375" y="6455664"/>
+            <a:off x="10774375" y="6437376"/>
             <a:ext cx="914400" cy="365760"/>
           </a:xfrm>
           <a:prstGeom prst="rect">
@@ -10957,9 +13314,9 @@
               </a:lnSpc>
             </a:pPr>
             <a:r>
-              <a:rPr sz="1100" b="0" i="0">
-                <a:solidFill>
-                  <a:srgbClr val="92988E"/>
+              <a:rPr sz="1200" b="1" i="0">
+                <a:solidFill>
+                  <a:srgbClr val="465753"/>
                 </a:solidFill>
                 <a:latin typeface="Arial"/>
               </a:rPr>
@@ -11575,7 +13932,7 @@
         </p:nvSpPr>
         <p:spPr>
           <a:xfrm>
-            <a:off x="502920" y="6455664"/>
+            <a:off x="502920" y="6437376"/>
             <a:ext cx="5486400" cy="365760"/>
           </a:xfrm>
           <a:prstGeom prst="rect">
@@ -11595,7 +13952,7 @@
               </a:lnSpc>
             </a:pPr>
             <a:r>
-              <a:rPr sz="1100" b="1" i="0">
+              <a:rPr sz="1200" b="1" i="0">
                 <a:solidFill>
                   <a:srgbClr val="465753"/>
                 </a:solidFill>
@@ -11604,9 +13961,9 @@
               <a:t>niva</a:t>
             </a:r>
             <a:r>
-              <a:rPr sz="1100" b="0" i="0">
-                <a:solidFill>
-                  <a:srgbClr val="92988E"/>
+              <a:rPr sz="1200" b="0" i="0">
+                <a:solidFill>
+                  <a:srgbClr val="465753"/>
                 </a:solidFill>
                 <a:latin typeface="Arial"/>
               </a:rPr>
@@ -11623,7 +13980,7 @@
         </p:nvSpPr>
         <p:spPr>
           <a:xfrm>
-            <a:off x="10774375" y="6455664"/>
+            <a:off x="10774375" y="6437376"/>
             <a:ext cx="914400" cy="365760"/>
           </a:xfrm>
           <a:prstGeom prst="rect">
@@ -11643,9 +14000,9 @@
               </a:lnSpc>
             </a:pPr>
             <a:r>
-              <a:rPr sz="1100" b="0" i="0">
-                <a:solidFill>
-                  <a:srgbClr val="92988E"/>
+              <a:rPr sz="1200" b="1" i="0">
+                <a:solidFill>
+                  <a:srgbClr val="465753"/>
                 </a:solidFill>
                 <a:latin typeface="Arial"/>
               </a:rPr>

</xml_diff>